<commit_message>
Swap in the 10-slide deck
Co-Authored-By: Claude Opus 5 (1M context) <noreply@anthropic.com>
</commit_message>
<xml_diff>
--- a/pitch/deck.pptx
+++ b/pitch/deck.pptx
@@ -12,9 +12,12 @@
     <p:sldId id="260" r:id="rId6"/>
     <p:sldId id="261" r:id="rId7"/>
     <p:sldId id="262" r:id="rId8"/>
+    <p:sldId id="263" r:id="rId9"/>
+    <p:sldId id="264" r:id="rId10"/>
+    <p:sldId id="265" r:id="rId11"/>
   </p:sldIdLst>
   <p:notesMasterIdLst>
-    <p:notesMasterId r:id="rId9"/>
+    <p:notesMasterId r:id="rId12"/>
   </p:notesMasterIdLst>
   <p:sldSz cx="9144000" cy="5143500"/>
   <p:notesSz cx="5143500" cy="9144000"/>
@@ -550,6 +553,94 @@
 </p:notes>
 </file>
 
+<file path=ppt/notesSlides/notesSlide10.xml><?xml version="1.0" encoding="utf-8"?>
+<p:notes xmlns:a="http://schemas.openxmlformats.org/drawingml/2006/main" xmlns:r="http://schemas.openxmlformats.org/officeDocument/2006/relationships" xmlns:p="http://schemas.openxmlformats.org/presentationml/2006/main">
+  <p:cSld>
+    <p:spTree>
+      <p:nvGrpSpPr>
+        <p:cNvPr id="1" name=""/>
+        <p:cNvGrpSpPr/>
+        <p:nvPr/>
+      </p:nvGrpSpPr>
+      <p:grpSpPr>
+        <a:xfrm>
+          <a:off x="0" y="0"/>
+          <a:ext cx="0" cy="0"/>
+          <a:chOff x="0" y="0"/>
+          <a:chExt cx="0" cy="0"/>
+        </a:xfrm>
+      </p:grpSpPr>
+      <p:sp>
+        <p:nvSpPr>
+          <p:cNvPr id="2" name="Slide Image Placeholder 1"/>
+          <p:cNvSpPr>
+            <a:spLocks noGrp="1" noRot="1" noChangeAspect="1"/>
+          </p:cNvSpPr>
+          <p:nvPr>
+            <p:ph type="sldImg"/>
+          </p:nvPr>
+        </p:nvSpPr>
+        <p:spPr/>
+      </p:sp>
+      <p:sp>
+        <p:nvSpPr>
+          <p:cNvPr id="3" name="Notes Placeholder 2"/>
+          <p:cNvSpPr>
+            <a:spLocks noGrp="1"/>
+          </p:cNvSpPr>
+          <p:nvPr>
+            <p:ph type="body" idx="1"/>
+          </p:nvPr>
+        </p:nvSpPr>
+        <p:spPr/>
+        <p:txBody>
+          <a:bodyPr/>
+          <a:lstStyle/>
+          <a:p>
+            <a:r>
+              <a:rPr lang="en-US" dirty="0"/>
+              <a:t>4:10-4:45 — The close. Name the next step out loud; do not let the slide do it alone. Swap the placeholder for a real booking link BEFORE recording.</a:t>
+            </a:r>
+            <a:endParaRPr lang="en-US" dirty="0"/>
+          </a:p>
+        </p:txBody>
+      </p:sp>
+      <p:sp>
+        <p:nvSpPr>
+          <p:cNvPr id="4" name="Slide Number Placeholder 3"/>
+          <p:cNvSpPr>
+            <a:spLocks noGrp="1"/>
+          </p:cNvSpPr>
+          <p:nvPr>
+            <p:ph type="sldNum" sz="quarter" idx="10"/>
+          </p:nvPr>
+        </p:nvSpPr>
+        <p:spPr/>
+        <p:txBody>
+          <a:bodyPr/>
+          <a:lstStyle/>
+          <a:p>
+            <a:fld id="{F7021451-1387-4CA6-816F-3879F97B5CBC}" type="slidenum">
+              <a:rPr lang="en-US"/>
+              <a:t>10</a:t>
+            </a:fld>
+            <a:endParaRPr lang="en-US"/>
+          </a:p>
+        </p:txBody>
+      </p:sp>
+    </p:spTree>
+    <p:extLst>
+      <p:ext uri="{BB962C8B-B14F-4D97-AF65-F5344CB8AC3E}">
+        <p14:creationId xmlns:p14="http://schemas.microsoft.com/office/powerpoint/2010/main" val="1024086991"/>
+      </p:ext>
+    </p:extLst>
+  </p:cSld>
+  <p:clrMapOvr>
+    <a:masterClrMapping/>
+  </p:clrMapOvr>
+</p:notes>
+</file>
+
 <file path=ppt/notesSlides/notesSlide2.xml><?xml version="1.0" encoding="utf-8"?>
 <p:notes xmlns:a="http://schemas.openxmlformats.org/drawingml/2006/main" xmlns:r="http://schemas.openxmlformats.org/officeDocument/2006/relationships" xmlns:p="http://schemas.openxmlformats.org/presentationml/2006/main">
   <p:cSld>
@@ -861,7 +952,7 @@
           <a:p>
             <a:r>
               <a:rPr lang="en-US" dirty="0"/>
-              <a:t>Flash card — two seconds, then switch to the live screen. Say the 'what I can build for you' line, not the description. The description is there so you remember the angle.</a:t>
+              <a:t>Say: nine slides that argue one thing — most roofs get replaced when they needed a repair. The diagrams are hand-drawn, not stock. Do not narrate each card.</a:t>
             </a:r>
             <a:endParaRPr lang="en-US" dirty="0"/>
           </a:p>
@@ -949,7 +1040,7 @@
           <a:p>
             <a:r>
               <a:rPr lang="en-US" dirty="0"/>
-              <a:t>Flash card — two seconds, then switch to the live screen. Say the 'what I can build for you' line, not the description. The description is there so you remember the angle.</a:t>
+              <a:t>The line that lands here: excluding Stories to dodge a bad crop is the wrong instinct — supply the right crop instead.</a:t>
             </a:r>
             <a:endParaRPr lang="en-US" dirty="0"/>
           </a:p>
@@ -1037,7 +1128,7 @@
           <a:p>
             <a:r>
               <a:rPr lang="en-US" dirty="0"/>
-              <a:t>4:10-4:45 — The close. Name the next step out loud; do not let the slide do it alone. Swap the placeholder for a real booking link BEFORE recording.</a:t>
+              <a:t>This is the strategy beat, and it is rarer than being able to make a nice image. Say: two of these share creative so the only variable is the copy, and one swaps the photo for a diagram against the same promise. A test you can learn from, not four guesses.</a:t>
             </a:r>
             <a:endParaRPr lang="en-US" dirty="0"/>
           </a:p>
@@ -1061,6 +1152,182 @@
             <a:fld id="{F7021451-1387-4CA6-816F-3879F97B5CBC}" type="slidenum">
               <a:rPr lang="en-US"/>
               <a:t>7</a:t>
+            </a:fld>
+            <a:endParaRPr lang="en-US"/>
+          </a:p>
+        </p:txBody>
+      </p:sp>
+    </p:spTree>
+    <p:extLst>
+      <p:ext uri="{BB962C8B-B14F-4D97-AF65-F5344CB8AC3E}">
+        <p14:creationId xmlns:p14="http://schemas.microsoft.com/office/powerpoint/2010/main" val="1024086991"/>
+      </p:ext>
+    </p:extLst>
+  </p:cSld>
+  <p:clrMapOvr>
+    <a:masterClrMapping/>
+  </p:clrMapOvr>
+</p:notes>
+</file>
+
+<file path=ppt/notesSlides/notesSlide8.xml><?xml version="1.0" encoding="utf-8"?>
+<p:notes xmlns:a="http://schemas.openxmlformats.org/drawingml/2006/main" xmlns:r="http://schemas.openxmlformats.org/officeDocument/2006/relationships" xmlns:p="http://schemas.openxmlformats.org/presentationml/2006/main">
+  <p:cSld>
+    <p:spTree>
+      <p:nvGrpSpPr>
+        <p:cNvPr id="1" name=""/>
+        <p:cNvGrpSpPr/>
+        <p:nvPr/>
+      </p:nvGrpSpPr>
+      <p:grpSpPr>
+        <a:xfrm>
+          <a:off x="0" y="0"/>
+          <a:ext cx="0" cy="0"/>
+          <a:chOff x="0" y="0"/>
+          <a:chExt cx="0" cy="0"/>
+        </a:xfrm>
+      </p:grpSpPr>
+      <p:sp>
+        <p:nvSpPr>
+          <p:cNvPr id="2" name="Slide Image Placeholder 1"/>
+          <p:cNvSpPr>
+            <a:spLocks noGrp="1" noRot="1" noChangeAspect="1"/>
+          </p:cNvSpPr>
+          <p:nvPr>
+            <p:ph type="sldImg"/>
+          </p:nvPr>
+        </p:nvSpPr>
+        <p:spPr/>
+      </p:sp>
+      <p:sp>
+        <p:nvSpPr>
+          <p:cNvPr id="3" name="Notes Placeholder 2"/>
+          <p:cNvSpPr>
+            <a:spLocks noGrp="1"/>
+          </p:cNvSpPr>
+          <p:nvPr>
+            <p:ph type="body" idx="1"/>
+          </p:nvPr>
+        </p:nvSpPr>
+        <p:spPr/>
+        <p:txBody>
+          <a:bodyPr/>
+          <a:lstStyle/>
+          <a:p>
+            <a:r>
+              <a:rPr lang="en-US" dirty="0"/>
+              <a:t>Flash card — two seconds, then switch to the live screen. Say the 'what I can build for you' line, not the description. The description is there so you remember the angle.</a:t>
+            </a:r>
+            <a:endParaRPr lang="en-US" dirty="0"/>
+          </a:p>
+        </p:txBody>
+      </p:sp>
+      <p:sp>
+        <p:nvSpPr>
+          <p:cNvPr id="4" name="Slide Number Placeholder 3"/>
+          <p:cNvSpPr>
+            <a:spLocks noGrp="1"/>
+          </p:cNvSpPr>
+          <p:nvPr>
+            <p:ph type="sldNum" sz="quarter" idx="10"/>
+          </p:nvPr>
+        </p:nvSpPr>
+        <p:spPr/>
+        <p:txBody>
+          <a:bodyPr/>
+          <a:lstStyle/>
+          <a:p>
+            <a:fld id="{F7021451-1387-4CA6-816F-3879F97B5CBC}" type="slidenum">
+              <a:rPr lang="en-US"/>
+              <a:t>8</a:t>
+            </a:fld>
+            <a:endParaRPr lang="en-US"/>
+          </a:p>
+        </p:txBody>
+      </p:sp>
+    </p:spTree>
+    <p:extLst>
+      <p:ext uri="{BB962C8B-B14F-4D97-AF65-F5344CB8AC3E}">
+        <p14:creationId xmlns:p14="http://schemas.microsoft.com/office/powerpoint/2010/main" val="1024086991"/>
+      </p:ext>
+    </p:extLst>
+  </p:cSld>
+  <p:clrMapOvr>
+    <a:masterClrMapping/>
+  </p:clrMapOvr>
+</p:notes>
+</file>
+
+<file path=ppt/notesSlides/notesSlide9.xml><?xml version="1.0" encoding="utf-8"?>
+<p:notes xmlns:a="http://schemas.openxmlformats.org/drawingml/2006/main" xmlns:r="http://schemas.openxmlformats.org/officeDocument/2006/relationships" xmlns:p="http://schemas.openxmlformats.org/presentationml/2006/main">
+  <p:cSld>
+    <p:spTree>
+      <p:nvGrpSpPr>
+        <p:cNvPr id="1" name=""/>
+        <p:cNvGrpSpPr/>
+        <p:nvPr/>
+      </p:nvGrpSpPr>
+      <p:grpSpPr>
+        <a:xfrm>
+          <a:off x="0" y="0"/>
+          <a:ext cx="0" cy="0"/>
+          <a:chOff x="0" y="0"/>
+          <a:chExt cx="0" cy="0"/>
+        </a:xfrm>
+      </p:grpSpPr>
+      <p:sp>
+        <p:nvSpPr>
+          <p:cNvPr id="2" name="Slide Image Placeholder 1"/>
+          <p:cNvSpPr>
+            <a:spLocks noGrp="1" noRot="1" noChangeAspect="1"/>
+          </p:cNvSpPr>
+          <p:nvPr>
+            <p:ph type="sldImg"/>
+          </p:nvPr>
+        </p:nvSpPr>
+        <p:spPr/>
+      </p:sp>
+      <p:sp>
+        <p:nvSpPr>
+          <p:cNvPr id="3" name="Notes Placeholder 2"/>
+          <p:cNvSpPr>
+            <a:spLocks noGrp="1"/>
+          </p:cNvSpPr>
+          <p:nvPr>
+            <p:ph type="body" idx="1"/>
+          </p:nvPr>
+        </p:nvSpPr>
+        <p:spPr/>
+        <p:txBody>
+          <a:bodyPr/>
+          <a:lstStyle/>
+          <a:p>
+            <a:r>
+              <a:rPr lang="en-US" dirty="0"/>
+              <a:t>Flash card — two seconds, then switch to the live screen. Say the 'what I can build for you' line, not the description. The description is there so you remember the angle.</a:t>
+            </a:r>
+            <a:endParaRPr lang="en-US" dirty="0"/>
+          </a:p>
+        </p:txBody>
+      </p:sp>
+      <p:sp>
+        <p:nvSpPr>
+          <p:cNvPr id="4" name="Slide Number Placeholder 3"/>
+          <p:cNvSpPr>
+            <a:spLocks noGrp="1"/>
+          </p:cNvSpPr>
+          <p:nvPr>
+            <p:ph type="sldNum" sz="quarter" idx="10"/>
+          </p:nvPr>
+        </p:nvSpPr>
+        <p:spPr/>
+        <p:txBody>
+          <a:bodyPr/>
+          <a:lstStyle/>
+          <a:p>
+            <a:fld id="{F7021451-1387-4CA6-816F-3879F97B5CBC}" type="slidenum">
+              <a:rPr lang="en-US"/>
+              <a:t>9</a:t>
             </a:fld>
             <a:endParaRPr lang="en-US"/>
           </a:p>
@@ -1621,6 +1888,513 @@
 </p:sld>
 </file>
 
+<file path=ppt/slides/slide10.xml><?xml version="1.0" encoding="utf-8"?>
+<p:sld xmlns:a="http://schemas.openxmlformats.org/drawingml/2006/main" xmlns:r="http://schemas.openxmlformats.org/officeDocument/2006/relationships" xmlns:p="http://schemas.openxmlformats.org/presentationml/2006/main">
+  <p:cSld name="Slide 10">
+    <p:bg>
+      <p:bgPr>
+        <a:solidFill>
+          <a:srgbClr val="16232E"/>
+        </a:solidFill>
+      </p:bgPr>
+    </p:bg>
+    <p:spTree>
+      <p:nvGrpSpPr>
+        <p:cNvPr id="1" name=""/>
+        <p:cNvGrpSpPr/>
+        <p:nvPr/>
+      </p:nvGrpSpPr>
+      <p:grpSpPr>
+        <a:xfrm>
+          <a:off x="0" y="0"/>
+          <a:ext cx="0" cy="0"/>
+          <a:chOff x="0" y="0"/>
+          <a:chExt cx="0" cy="0"/>
+        </a:xfrm>
+      </p:grpSpPr>
+      <p:sp>
+        <p:nvSpPr>
+          <p:cNvPr id="2" name="Shape 0"/>
+          <p:cNvSpPr/>
+          <p:nvPr/>
+        </p:nvSpPr>
+        <p:spPr>
+          <a:xfrm>
+            <a:off x="-1005840" y="2286000"/>
+            <a:ext cx="3291840" cy="3291840"/>
+          </a:xfrm>
+          <a:prstGeom prst="ellipse">
+            <a:avLst/>
+          </a:prstGeom>
+          <a:ln w="15875">
+            <a:solidFill>
+              <a:srgbClr val="C4622D"/>
+            </a:solidFill>
+            <a:prstDash val="solid"/>
+          </a:ln>
+        </p:spPr>
+      </p:sp>
+      <p:sp>
+        <p:nvSpPr>
+          <p:cNvPr id="3" name="Text 1"/>
+          <p:cNvSpPr/>
+          <p:nvPr/>
+        </p:nvSpPr>
+        <p:spPr>
+          <a:xfrm>
+            <a:off x="548640" y="658368"/>
+            <a:ext cx="8046720" cy="365760"/>
+          </a:xfrm>
+          <a:prstGeom prst="rect">
+            <a:avLst/>
+          </a:prstGeom>
+          <a:noFill/>
+          <a:ln/>
+        </p:spPr>
+        <p:txBody>
+          <a:bodyPr wrap="square" lIns="0" tIns="0" rIns="0" bIns="0" rtlCol="0" anchor="ctr"/>
+          <a:lstStyle/>
+          <a:p>
+            <a:pPr indent="0" marL="0">
+              <a:buNone/>
+            </a:pPr>
+            <a:r>
+              <a:rPr lang="en-US" sz="1200" b="1" spc="220" kern="0" dirty="0">
+                <a:solidFill>
+                  <a:srgbClr val="C4622D"/>
+                </a:solidFill>
+                <a:latin typeface="Calibri" pitchFamily="34" charset="0"/>
+                <a:ea typeface="Calibri" pitchFamily="34" charset="-122"/>
+                <a:cs typeface="Calibri" pitchFamily="34" charset="-120"/>
+              </a:rPr>
+              <a:t>If you are running the business</a:t>
+            </a:r>
+            <a:endParaRPr lang="en-US" sz="1200" dirty="0"/>
+          </a:p>
+        </p:txBody>
+      </p:sp>
+      <p:sp>
+        <p:nvSpPr>
+          <p:cNvPr id="4" name="Text 2"/>
+          <p:cNvSpPr/>
+          <p:nvPr/>
+        </p:nvSpPr>
+        <p:spPr>
+          <a:xfrm>
+            <a:off x="530352" y="1115568"/>
+            <a:ext cx="8046720" cy="731520"/>
+          </a:xfrm>
+          <a:prstGeom prst="rect">
+            <a:avLst/>
+          </a:prstGeom>
+          <a:noFill/>
+          <a:ln/>
+        </p:spPr>
+        <p:txBody>
+          <a:bodyPr wrap="square" lIns="0" tIns="0" rIns="0" bIns="0" rtlCol="0" anchor="ctr"/>
+          <a:lstStyle/>
+          <a:p>
+            <a:pPr indent="0" marL="0">
+              <a:buNone/>
+            </a:pPr>
+            <a:r>
+              <a:rPr lang="en-US" sz="4000" b="1" dirty="0">
+                <a:solidFill>
+                  <a:srgbClr val="F6F4EF"/>
+                </a:solidFill>
+                <a:latin typeface="Cambria" pitchFamily="34" charset="0"/>
+                <a:ea typeface="Cambria" pitchFamily="34" charset="-122"/>
+                <a:cs typeface="Cambria" pitchFamily="34" charset="-120"/>
+              </a:rPr>
+              <a:t>I can build this for you.</a:t>
+            </a:r>
+            <a:endParaRPr lang="en-US" sz="4000" dirty="0"/>
+          </a:p>
+        </p:txBody>
+      </p:sp>
+      <p:sp>
+        <p:nvSpPr>
+          <p:cNvPr id="5" name="Shape 3"/>
+          <p:cNvSpPr/>
+          <p:nvPr/>
+        </p:nvSpPr>
+        <p:spPr>
+          <a:xfrm>
+            <a:off x="603504" y="2176272"/>
+            <a:ext cx="128016" cy="128016"/>
+          </a:xfrm>
+          <a:prstGeom prst="ellipse">
+            <a:avLst/>
+          </a:prstGeom>
+          <a:solidFill>
+            <a:srgbClr val="C4622D"/>
+          </a:solidFill>
+          <a:ln/>
+        </p:spPr>
+      </p:sp>
+      <p:sp>
+        <p:nvSpPr>
+          <p:cNvPr id="6" name="Text 4"/>
+          <p:cNvSpPr/>
+          <p:nvPr/>
+        </p:nvSpPr>
+        <p:spPr>
+          <a:xfrm>
+            <a:off x="914400" y="2084832"/>
+            <a:ext cx="4937760" cy="329184"/>
+          </a:xfrm>
+          <a:prstGeom prst="rect">
+            <a:avLst/>
+          </a:prstGeom>
+          <a:noFill/>
+          <a:ln/>
+        </p:spPr>
+        <p:txBody>
+          <a:bodyPr wrap="square" lIns="0" tIns="0" rIns="0" bIns="0" rtlCol="0" anchor="ctr"/>
+          <a:lstStyle/>
+          <a:p>
+            <a:pPr indent="0" marL="0">
+              <a:buNone/>
+            </a:pPr>
+            <a:r>
+              <a:rPr lang="en-US" sz="1500" dirty="0">
+                <a:solidFill>
+                  <a:srgbClr val="F6F4EF"/>
+                </a:solidFill>
+                <a:latin typeface="Calibri" pitchFamily="34" charset="0"/>
+                <a:ea typeface="Calibri" pitchFamily="34" charset="-122"/>
+                <a:cs typeface="Calibri" pitchFamily="34" charset="-120"/>
+              </a:rPr>
+              <a:t>Your CRM set up, with every lead in one place</a:t>
+            </a:r>
+            <a:endParaRPr lang="en-US" sz="1500" dirty="0"/>
+          </a:p>
+        </p:txBody>
+      </p:sp>
+      <p:sp>
+        <p:nvSpPr>
+          <p:cNvPr id="7" name="Shape 5"/>
+          <p:cNvSpPr/>
+          <p:nvPr/>
+        </p:nvSpPr>
+        <p:spPr>
+          <a:xfrm>
+            <a:off x="603504" y="2578608"/>
+            <a:ext cx="128016" cy="128016"/>
+          </a:xfrm>
+          <a:prstGeom prst="ellipse">
+            <a:avLst/>
+          </a:prstGeom>
+          <a:solidFill>
+            <a:srgbClr val="C4622D"/>
+          </a:solidFill>
+          <a:ln/>
+        </p:spPr>
+      </p:sp>
+      <p:sp>
+        <p:nvSpPr>
+          <p:cNvPr id="8" name="Text 6"/>
+          <p:cNvSpPr/>
+          <p:nvPr/>
+        </p:nvSpPr>
+        <p:spPr>
+          <a:xfrm>
+            <a:off x="914400" y="2487168"/>
+            <a:ext cx="4937760" cy="329184"/>
+          </a:xfrm>
+          <a:prstGeom prst="rect">
+            <a:avLst/>
+          </a:prstGeom>
+          <a:noFill/>
+          <a:ln/>
+        </p:spPr>
+        <p:txBody>
+          <a:bodyPr wrap="square" lIns="0" tIns="0" rIns="0" bIns="0" rtlCol="0" anchor="ctr"/>
+          <a:lstStyle/>
+          <a:p>
+            <a:pPr indent="0" marL="0">
+              <a:buNone/>
+            </a:pPr>
+            <a:r>
+              <a:rPr lang="en-US" sz="1500" dirty="0">
+                <a:solidFill>
+                  <a:srgbClr val="F6F4EF"/>
+                </a:solidFill>
+                <a:latin typeface="Calibri" pitchFamily="34" charset="0"/>
+                <a:ea typeface="Calibri" pitchFamily="34" charset="-122"/>
+                <a:cs typeface="Calibri" pitchFamily="34" charset="-120"/>
+              </a:rPr>
+              <a:t>The funnel and the page that fills it</a:t>
+            </a:r>
+            <a:endParaRPr lang="en-US" sz="1500" dirty="0"/>
+          </a:p>
+        </p:txBody>
+      </p:sp>
+      <p:sp>
+        <p:nvSpPr>
+          <p:cNvPr id="9" name="Shape 7"/>
+          <p:cNvSpPr/>
+          <p:nvPr/>
+        </p:nvSpPr>
+        <p:spPr>
+          <a:xfrm>
+            <a:off x="603504" y="2980944"/>
+            <a:ext cx="128016" cy="128016"/>
+          </a:xfrm>
+          <a:prstGeom prst="ellipse">
+            <a:avLst/>
+          </a:prstGeom>
+          <a:solidFill>
+            <a:srgbClr val="C4622D"/>
+          </a:solidFill>
+          <a:ln/>
+        </p:spPr>
+      </p:sp>
+      <p:sp>
+        <p:nvSpPr>
+          <p:cNvPr id="10" name="Text 8"/>
+          <p:cNvSpPr/>
+          <p:nvPr/>
+        </p:nvSpPr>
+        <p:spPr>
+          <a:xfrm>
+            <a:off x="914400" y="2889504"/>
+            <a:ext cx="4937760" cy="329184"/>
+          </a:xfrm>
+          <a:prstGeom prst="rect">
+            <a:avLst/>
+          </a:prstGeom>
+          <a:noFill/>
+          <a:ln/>
+        </p:spPr>
+        <p:txBody>
+          <a:bodyPr wrap="square" lIns="0" tIns="0" rIns="0" bIns="0" rtlCol="0" anchor="ctr"/>
+          <a:lstStyle/>
+          <a:p>
+            <a:pPr indent="0" marL="0">
+              <a:buNone/>
+            </a:pPr>
+            <a:r>
+              <a:rPr lang="en-US" sz="1500" dirty="0">
+                <a:solidFill>
+                  <a:srgbClr val="F6F4EF"/>
+                </a:solidFill>
+                <a:latin typeface="Calibri" pitchFamily="34" charset="0"/>
+                <a:ea typeface="Calibri" pitchFamily="34" charset="-122"/>
+                <a:cs typeface="Calibri" pitchFamily="34" charset="-120"/>
+              </a:rPr>
+              <a:t>The ads that feed the page</a:t>
+            </a:r>
+            <a:endParaRPr lang="en-US" sz="1500" dirty="0"/>
+          </a:p>
+        </p:txBody>
+      </p:sp>
+      <p:sp>
+        <p:nvSpPr>
+          <p:cNvPr id="11" name="Shape 9"/>
+          <p:cNvSpPr/>
+          <p:nvPr/>
+        </p:nvSpPr>
+        <p:spPr>
+          <a:xfrm>
+            <a:off x="603504" y="3383280"/>
+            <a:ext cx="128016" cy="128016"/>
+          </a:xfrm>
+          <a:prstGeom prst="ellipse">
+            <a:avLst/>
+          </a:prstGeom>
+          <a:solidFill>
+            <a:srgbClr val="C4622D"/>
+          </a:solidFill>
+          <a:ln/>
+        </p:spPr>
+      </p:sp>
+      <p:sp>
+        <p:nvSpPr>
+          <p:cNvPr id="12" name="Text 10"/>
+          <p:cNvSpPr/>
+          <p:nvPr/>
+        </p:nvSpPr>
+        <p:spPr>
+          <a:xfrm>
+            <a:off x="914400" y="3291840"/>
+            <a:ext cx="4937760" cy="329184"/>
+          </a:xfrm>
+          <a:prstGeom prst="rect">
+            <a:avLst/>
+          </a:prstGeom>
+          <a:noFill/>
+          <a:ln/>
+        </p:spPr>
+        <p:txBody>
+          <a:bodyPr wrap="square" lIns="0" tIns="0" rIns="0" bIns="0" rtlCol="0" anchor="ctr"/>
+          <a:lstStyle/>
+          <a:p>
+            <a:pPr indent="0" marL="0">
+              <a:buNone/>
+            </a:pPr>
+            <a:r>
+              <a:rPr lang="en-US" sz="1500" dirty="0">
+                <a:solidFill>
+                  <a:srgbClr val="F6F4EF"/>
+                </a:solidFill>
+                <a:latin typeface="Calibri" pitchFamily="34" charset="0"/>
+                <a:ea typeface="Calibri" pitchFamily="34" charset="-122"/>
+                <a:cs typeface="Calibri" pitchFamily="34" charset="-120"/>
+              </a:rPr>
+              <a:t>The follow-up that runs on its own</a:t>
+            </a:r>
+            <a:endParaRPr lang="en-US" sz="1500" dirty="0"/>
+          </a:p>
+        </p:txBody>
+      </p:sp>
+      <p:sp>
+        <p:nvSpPr>
+          <p:cNvPr id="13" name="Shape 11"/>
+          <p:cNvSpPr/>
+          <p:nvPr/>
+        </p:nvSpPr>
+        <p:spPr>
+          <a:xfrm>
+            <a:off x="5989320" y="2103120"/>
+            <a:ext cx="2606040" cy="841248"/>
+          </a:xfrm>
+          <a:prstGeom prst="roundRect">
+            <a:avLst>
+              <a:gd name="adj" fmla="val 6522"/>
+            </a:avLst>
+          </a:prstGeom>
+          <a:solidFill>
+            <a:srgbClr val="C4622D"/>
+          </a:solidFill>
+          <a:ln/>
+        </p:spPr>
+      </p:sp>
+      <p:sp>
+        <p:nvSpPr>
+          <p:cNvPr id="14" name="Text 12"/>
+          <p:cNvSpPr/>
+          <p:nvPr/>
+        </p:nvSpPr>
+        <p:spPr>
+          <a:xfrm>
+            <a:off x="5989320" y="2103120"/>
+            <a:ext cx="2606040" cy="841248"/>
+          </a:xfrm>
+          <a:prstGeom prst="rect">
+            <a:avLst/>
+          </a:prstGeom>
+          <a:noFill/>
+          <a:ln/>
+        </p:spPr>
+        <p:txBody>
+          <a:bodyPr wrap="square" lIns="0" tIns="0" rIns="0" bIns="0" rtlCol="0" anchor="ctr"/>
+          <a:lstStyle/>
+          <a:p>
+            <a:pPr algn="ctr" indent="0" marL="0">
+              <a:buNone/>
+            </a:pPr>
+            <a:r>
+              <a:rPr lang="en-US" sz="1600" b="1" dirty="0">
+                <a:solidFill>
+                  <a:srgbClr val="F6F4EF"/>
+                </a:solidFill>
+                <a:latin typeface="Calibri" pitchFamily="34" charset="0"/>
+                <a:ea typeface="Calibri" pitchFamily="34" charset="-122"/>
+                <a:cs typeface="Calibri" pitchFamily="34" charset="-120"/>
+              </a:rPr>
+              <a:t>Book a call with me</a:t>
+            </a:r>
+            <a:endParaRPr lang="en-US" sz="1600" dirty="0"/>
+          </a:p>
+        </p:txBody>
+      </p:sp>
+      <p:sp>
+        <p:nvSpPr>
+          <p:cNvPr id="15" name="Text 13"/>
+          <p:cNvSpPr/>
+          <p:nvPr/>
+        </p:nvSpPr>
+        <p:spPr>
+          <a:xfrm>
+            <a:off x="5989320" y="3035808"/>
+            <a:ext cx="2606040" cy="274320"/>
+          </a:xfrm>
+          <a:prstGeom prst="rect">
+            <a:avLst/>
+          </a:prstGeom>
+          <a:noFill/>
+          <a:ln/>
+        </p:spPr>
+        <p:txBody>
+          <a:bodyPr wrap="square" lIns="0" tIns="0" rIns="0" bIns="0" rtlCol="0" anchor="ctr"/>
+          <a:lstStyle/>
+          <a:p>
+            <a:pPr algn="ctr" indent="0" marL="0">
+              <a:buNone/>
+            </a:pPr>
+            <a:r>
+              <a:rPr lang="en-US" sz="1050" b="1" spc="60" kern="0" dirty="0">
+                <a:solidFill>
+                  <a:srgbClr val="3E6B57"/>
+                </a:solidFill>
+                <a:latin typeface="Calibri" pitchFamily="34" charset="0"/>
+                <a:ea typeface="Calibri" pitchFamily="34" charset="-122"/>
+                <a:cs typeface="Calibri" pitchFamily="34" charset="-120"/>
+              </a:rPr>
+              <a:t>REPLACE WITH YOUR BOOKING LINK</a:t>
+            </a:r>
+            <a:endParaRPr lang="en-US" sz="1050" dirty="0"/>
+          </a:p>
+        </p:txBody>
+      </p:sp>
+      <p:sp>
+        <p:nvSpPr>
+          <p:cNvPr id="16" name="Text 14"/>
+          <p:cNvSpPr/>
+          <p:nvPr/>
+        </p:nvSpPr>
+        <p:spPr>
+          <a:xfrm>
+            <a:off x="548640" y="4224528"/>
+            <a:ext cx="3657600" cy="292608"/>
+          </a:xfrm>
+          <a:prstGeom prst="rect">
+            <a:avLst/>
+          </a:prstGeom>
+          <a:noFill/>
+          <a:ln/>
+        </p:spPr>
+        <p:txBody>
+          <a:bodyPr wrap="square" lIns="0" tIns="0" rIns="0" bIns="0" rtlCol="0" anchor="ctr"/>
+          <a:lstStyle/>
+          <a:p>
+            <a:pPr indent="0" marL="0">
+              <a:buNone/>
+            </a:pPr>
+            <a:r>
+              <a:rPr lang="en-US" sz="1500" b="1" dirty="0">
+                <a:solidFill>
+                  <a:srgbClr val="F6F4EF"/>
+                </a:solidFill>
+                <a:latin typeface="Cambria" pitchFamily="34" charset="0"/>
+                <a:ea typeface="Cambria" pitchFamily="34" charset="-122"/>
+                <a:cs typeface="Cambria" pitchFamily="34" charset="-120"/>
+              </a:rPr>
+              <a:t>Peter Gutierrez</a:t>
+            </a:r>
+            <a:endParaRPr lang="en-US" sz="1500" dirty="0"/>
+          </a:p>
+        </p:txBody>
+      </p:sp>
+    </p:spTree>
+  </p:cSld>
+  <p:clrMapOvr>
+    <a:masterClrMapping/>
+  </p:clrMapOvr>
+</p:sld>
+</file>
+
 <file path=ppt/slides/slide2.xml><?xml version="1.0" encoding="utf-8"?>
 <p:sld xmlns:a="http://schemas.openxmlformats.org/drawingml/2006/main" xmlns:r="http://schemas.openxmlformats.org/officeDocument/2006/relationships" xmlns:p="http://schemas.openxmlformats.org/presentationml/2006/main">
   <p:cSld name="Slide 2">
@@ -2923,36 +3697,14 @@
       </p:grpSpPr>
       <p:sp>
         <p:nvSpPr>
-          <p:cNvPr id="2" name="Shape 0"/>
-          <p:cNvSpPr/>
-          <p:nvPr/>
-        </p:nvSpPr>
-        <p:spPr>
-          <a:xfrm>
-            <a:off x="6949440" y="960120"/>
-            <a:ext cx="3108960" cy="3108960"/>
-          </a:xfrm>
-          <a:prstGeom prst="ellipse">
-            <a:avLst/>
-          </a:prstGeom>
-          <a:ln w="15875">
-            <a:solidFill>
-              <a:srgbClr val="C4622D"/>
-            </a:solidFill>
-            <a:prstDash val="solid"/>
-          </a:ln>
-        </p:spPr>
-      </p:sp>
-      <p:sp>
-        <p:nvSpPr>
-          <p:cNvPr id="3" name="Text 1"/>
-          <p:cNvSpPr/>
-          <p:nvPr/>
-        </p:nvSpPr>
-        <p:spPr>
-          <a:xfrm>
-            <a:off x="566928" y="658368"/>
-            <a:ext cx="1097280" cy="365760"/>
+          <p:cNvPr id="2" name="Text 0"/>
+          <p:cNvSpPr/>
+          <p:nvPr/>
+        </p:nvSpPr>
+        <p:spPr>
+          <a:xfrm>
+            <a:off x="566928" y="384048"/>
+            <a:ext cx="5486400" cy="274320"/>
           </a:xfrm>
           <a:prstGeom prst="rect">
             <a:avLst/>
@@ -2968,7 +3720,7 @@
               <a:buNone/>
             </a:pPr>
             <a:r>
-              <a:rPr lang="en-US" sz="1200" b="1" spc="240" kern="0" dirty="0">
+              <a:rPr lang="en-US" sz="1100" b="1" spc="220" kern="0" dirty="0">
                 <a:solidFill>
                   <a:srgbClr val="C4622D"/>
                 </a:solidFill>
@@ -2976,22 +3728,22 @@
                 <a:ea typeface="Calibri" pitchFamily="34" charset="-122"/>
                 <a:cs typeface="Calibri" pitchFamily="34" charset="-120"/>
               </a:rPr>
-              <a:t>03</a:t>
-            </a:r>
-            <a:endParaRPr lang="en-US" sz="1200" dirty="0"/>
-          </a:p>
-        </p:txBody>
-      </p:sp>
-      <p:sp>
-        <p:nvSpPr>
-          <p:cNvPr id="4" name="Text 2"/>
-          <p:cNvSpPr/>
-          <p:nvPr/>
-        </p:nvSpPr>
-        <p:spPr>
-          <a:xfrm>
-            <a:off x="548640" y="1188720"/>
-            <a:ext cx="5852160" cy="731520"/>
+              <a:t>NINE SLIDES, ONE ARGUMENT</a:t>
+            </a:r>
+            <a:endParaRPr lang="en-US" sz="1100" dirty="0"/>
+          </a:p>
+        </p:txBody>
+      </p:sp>
+      <p:sp>
+        <p:nvSpPr>
+          <p:cNvPr id="3" name="Text 1"/>
+          <p:cNvSpPr/>
+          <p:nvPr/>
+        </p:nvSpPr>
+        <p:spPr>
+          <a:xfrm>
+            <a:off x="548640" y="713232"/>
+            <a:ext cx="8046720" cy="457200"/>
           </a:xfrm>
           <a:prstGeom prst="rect">
             <a:avLst/>
@@ -3007,7 +3759,7 @@
               <a:buNone/>
             </a:pPr>
             <a:r>
-              <a:rPr lang="en-US" sz="4000" b="1" dirty="0">
+              <a:rPr lang="en-US" sz="2700" b="1" dirty="0">
                 <a:solidFill>
                   <a:srgbClr val="F6F4EF"/>
                 </a:solidFill>
@@ -3015,112 +3767,258 @@
                 <a:ea typeface="Cambria" pitchFamily="34" charset="-122"/>
                 <a:cs typeface="Cambria" pitchFamily="34" charset="-120"/>
               </a:rPr>
-              <a:t>The CRM</a:t>
-            </a:r>
-            <a:endParaRPr lang="en-US" sz="4000" dirty="0"/>
-          </a:p>
-        </p:txBody>
-      </p:sp>
-      <p:sp>
-        <p:nvSpPr>
-          <p:cNvPr id="5" name="Text 3"/>
-          <p:cNvSpPr/>
-          <p:nvPr/>
-        </p:nvSpPr>
-        <p:spPr>
-          <a:xfrm>
-            <a:off x="566928" y="2121408"/>
-            <a:ext cx="5486400" cy="914400"/>
-          </a:xfrm>
-          <a:prstGeom prst="rect">
-            <a:avLst/>
-          </a:prstGeom>
-          <a:noFill/>
-          <a:ln/>
-        </p:spPr>
-        <p:txBody>
-          <a:bodyPr wrap="square" lIns="0" tIns="0" rIns="0" bIns="0" rtlCol="0" anchor="ctr"/>
-          <a:lstStyle/>
-          <a:p>
-            <a:pPr indent="0" marL="0">
-              <a:lnSpc>
-                <a:spcPts val="2300"/>
-              </a:lnSpc>
-              <a:buNone/>
-            </a:pPr>
-            <a:r>
-              <a:rPr lang="en-US" sz="1500" dirty="0">
-                <a:solidFill>
-                  <a:srgbClr val="F6F4EF"/>
+              <a:t>Hook, six signs, then the counterweight</a:t>
+            </a:r>
+            <a:endParaRPr lang="en-US" sz="2700" dirty="0"/>
+          </a:p>
+        </p:txBody>
+      </p:sp>
+      <p:pic>
+        <p:nvPicPr>
+          <p:cNvPr id="4" name="Image 0" descr="img/card-hook.png">    </p:cNvPr>
+          <p:cNvPicPr>
+            <a:picLocks noChangeAspect="1"/>
+          </p:cNvPicPr>
+          <p:nvPr/>
+        </p:nvPicPr>
+        <p:blipFill>
+          <a:blip r:embed="rId1"/>
+          <a:stretch>
+            <a:fillRect/>
+          </a:stretch>
+        </p:blipFill>
+        <p:spPr>
+          <a:xfrm>
+            <a:off x="658368" y="1371600"/>
+            <a:ext cx="2121408" cy="2651760"/>
+          </a:xfrm>
+          <a:prstGeom prst="rect">
+            <a:avLst/>
+          </a:prstGeom>
+          <a:effectLst>
+            <a:outerShdw sx="100000" sy="100000" kx="0" ky="0" algn="bl" rotWithShape="0" blurRad="152400" dist="38100" dir="5400000">
+              <a:srgbClr val="000000">
+                <a:alpha val="35000"/>
+              </a:srgbClr>
+            </a:outerShdw>
+          </a:effectLst>
+        </p:spPr>
+      </p:pic>
+      <p:sp>
+        <p:nvSpPr>
+          <p:cNvPr id="5" name="Text 2"/>
+          <p:cNvSpPr/>
+          <p:nvPr/>
+        </p:nvSpPr>
+        <p:spPr>
+          <a:xfrm>
+            <a:off x="658368" y="4114800"/>
+            <a:ext cx="2121408" cy="256032"/>
+          </a:xfrm>
+          <a:prstGeom prst="rect">
+            <a:avLst/>
+          </a:prstGeom>
+          <a:noFill/>
+          <a:ln/>
+        </p:spPr>
+        <p:txBody>
+          <a:bodyPr wrap="square" lIns="0" tIns="0" rIns="0" bIns="0" rtlCol="0" anchor="ctr"/>
+          <a:lstStyle/>
+          <a:p>
+            <a:pPr algn="ctr" indent="0" marL="0">
+              <a:buNone/>
+            </a:pPr>
+            <a:r>
+              <a:rPr lang="en-US" sz="1100" dirty="0">
+                <a:solidFill>
+                  <a:srgbClr val="9AA7B2"/>
                 </a:solidFill>
                 <a:latin typeface="Calibri" pitchFamily="34" charset="0"/>
                 <a:ea typeface="Calibri" pitchFamily="34" charset="-122"/>
                 <a:cs typeface="Calibri" pitchFamily="34" charset="-120"/>
               </a:rPr>
-              <a:t>Six stages from new lead to won, fifteen real leads on the board, and dead deals that keep their history.</a:t>
-            </a:r>
-            <a:endParaRPr lang="en-US" sz="1500" dirty="0"/>
-          </a:p>
-        </p:txBody>
-      </p:sp>
-      <p:sp>
-        <p:nvSpPr>
-          <p:cNvPr id="6" name="Shape 4"/>
-          <p:cNvSpPr/>
-          <p:nvPr/>
-        </p:nvSpPr>
-        <p:spPr>
-          <a:xfrm>
-            <a:off x="548640" y="3401568"/>
-            <a:ext cx="5669280" cy="713232"/>
-          </a:xfrm>
-          <a:prstGeom prst="roundRect">
-            <a:avLst>
-              <a:gd name="adj" fmla="val 6410"/>
-            </a:avLst>
-          </a:prstGeom>
-          <a:solidFill>
-            <a:srgbClr val="2C4356"/>
-          </a:solidFill>
-          <a:ln/>
-        </p:spPr>
-      </p:sp>
-      <p:sp>
-        <p:nvSpPr>
-          <p:cNvPr id="7" name="Text 5"/>
-          <p:cNvSpPr/>
-          <p:nvPr/>
-        </p:nvSpPr>
-        <p:spPr>
-          <a:xfrm>
-            <a:off x="777240" y="3401568"/>
-            <a:ext cx="5212080" cy="713232"/>
-          </a:xfrm>
-          <a:prstGeom prst="rect">
-            <a:avLst/>
-          </a:prstGeom>
-          <a:noFill/>
-          <a:ln/>
-        </p:spPr>
-        <p:txBody>
-          <a:bodyPr wrap="square" lIns="0" tIns="0" rIns="0" bIns="0" rtlCol="0" anchor="ctr"/>
-          <a:lstStyle/>
-          <a:p>
-            <a:pPr indent="0" marL="0">
-              <a:buNone/>
-            </a:pPr>
-            <a:r>
-              <a:rPr lang="en-US" sz="1350" b="1" dirty="0">
-                <a:solidFill>
-                  <a:srgbClr val="F6F4EF"/>
+              <a:t>01 · the hook</a:t>
+            </a:r>
+            <a:endParaRPr lang="en-US" sz="1100" dirty="0"/>
+          </a:p>
+        </p:txBody>
+      </p:sp>
+      <p:pic>
+        <p:nvPicPr>
+          <p:cNvPr id="6" name="Image 1" descr="img/card-sign.png">    </p:cNvPr>
+          <p:cNvPicPr>
+            <a:picLocks noChangeAspect="1"/>
+          </p:cNvPicPr>
+          <p:nvPr/>
+        </p:nvPicPr>
+        <p:blipFill>
+          <a:blip r:embed="rId2"/>
+          <a:stretch>
+            <a:fillRect/>
+          </a:stretch>
+        </p:blipFill>
+        <p:spPr>
+          <a:xfrm>
+            <a:off x="3328416" y="1371600"/>
+            <a:ext cx="2121408" cy="2651760"/>
+          </a:xfrm>
+          <a:prstGeom prst="rect">
+            <a:avLst/>
+          </a:prstGeom>
+          <a:effectLst>
+            <a:outerShdw sx="100000" sy="100000" kx="0" ky="0" algn="bl" rotWithShape="0" blurRad="152400" dist="38100" dir="5400000">
+              <a:srgbClr val="000000">
+                <a:alpha val="35000"/>
+              </a:srgbClr>
+            </a:outerShdw>
+          </a:effectLst>
+        </p:spPr>
+      </p:pic>
+      <p:sp>
+        <p:nvSpPr>
+          <p:cNvPr id="7" name="Text 3"/>
+          <p:cNvSpPr/>
+          <p:nvPr/>
+        </p:nvSpPr>
+        <p:spPr>
+          <a:xfrm>
+            <a:off x="3328416" y="4114800"/>
+            <a:ext cx="2121408" cy="256032"/>
+          </a:xfrm>
+          <a:prstGeom prst="rect">
+            <a:avLst/>
+          </a:prstGeom>
+          <a:noFill/>
+          <a:ln/>
+        </p:spPr>
+        <p:txBody>
+          <a:bodyPr wrap="square" lIns="0" tIns="0" rIns="0" bIns="0" rtlCol="0" anchor="ctr"/>
+          <a:lstStyle/>
+          <a:p>
+            <a:pPr algn="ctr" indent="0" marL="0">
+              <a:buNone/>
+            </a:pPr>
+            <a:r>
+              <a:rPr lang="en-US" sz="1100" dirty="0">
+                <a:solidFill>
+                  <a:srgbClr val="9AA7B2"/>
                 </a:solidFill>
                 <a:latin typeface="Calibri" pitchFamily="34" charset="0"/>
                 <a:ea typeface="Calibri" pitchFamily="34" charset="-122"/>
                 <a:cs typeface="Calibri" pitchFamily="34" charset="-120"/>
               </a:rPr>
-              <a:t>What I can build for you: a pipeline that tells you where money actually stalls.</a:t>
-            </a:r>
-            <a:endParaRPr lang="en-US" sz="1350" dirty="0"/>
+              <a:t>03 · one of six signs</a:t>
+            </a:r>
+            <a:endParaRPr lang="en-US" sz="1100" dirty="0"/>
+          </a:p>
+        </p:txBody>
+      </p:sp>
+      <p:pic>
+        <p:nvPicPr>
+          <p:cNvPr id="8" name="Image 2" descr="img/card-cta.png">    </p:cNvPr>
+          <p:cNvPicPr>
+            <a:picLocks noChangeAspect="1"/>
+          </p:cNvPicPr>
+          <p:nvPr/>
+        </p:nvPicPr>
+        <p:blipFill>
+          <a:blip r:embed="rId3"/>
+          <a:stretch>
+            <a:fillRect/>
+          </a:stretch>
+        </p:blipFill>
+        <p:spPr>
+          <a:xfrm>
+            <a:off x="5998464" y="1371600"/>
+            <a:ext cx="2121408" cy="2651760"/>
+          </a:xfrm>
+          <a:prstGeom prst="rect">
+            <a:avLst/>
+          </a:prstGeom>
+          <a:effectLst>
+            <a:outerShdw sx="100000" sy="100000" kx="0" ky="0" algn="bl" rotWithShape="0" blurRad="152400" dist="38100" dir="5400000">
+              <a:srgbClr val="000000">
+                <a:alpha val="35000"/>
+              </a:srgbClr>
+            </a:outerShdw>
+          </a:effectLst>
+        </p:spPr>
+      </p:pic>
+      <p:sp>
+        <p:nvSpPr>
+          <p:cNvPr id="9" name="Text 4"/>
+          <p:cNvSpPr/>
+          <p:nvPr/>
+        </p:nvSpPr>
+        <p:spPr>
+          <a:xfrm>
+            <a:off x="5998464" y="4114800"/>
+            <a:ext cx="2121408" cy="256032"/>
+          </a:xfrm>
+          <a:prstGeom prst="rect">
+            <a:avLst/>
+          </a:prstGeom>
+          <a:noFill/>
+          <a:ln/>
+        </p:spPr>
+        <p:txBody>
+          <a:bodyPr wrap="square" lIns="0" tIns="0" rIns="0" bIns="0" rtlCol="0" anchor="ctr"/>
+          <a:lstStyle/>
+          <a:p>
+            <a:pPr algn="ctr" indent="0" marL="0">
+              <a:buNone/>
+            </a:pPr>
+            <a:r>
+              <a:rPr lang="en-US" sz="1100" dirty="0">
+                <a:solidFill>
+                  <a:srgbClr val="9AA7B2"/>
+                </a:solidFill>
+                <a:latin typeface="Calibri" pitchFamily="34" charset="0"/>
+                <a:ea typeface="Calibri" pitchFamily="34" charset="-122"/>
+                <a:cs typeface="Calibri" pitchFamily="34" charset="-120"/>
+              </a:rPr>
+              <a:t>09 · the ask</a:t>
+            </a:r>
+            <a:endParaRPr lang="en-US" sz="1100" dirty="0"/>
+          </a:p>
+        </p:txBody>
+      </p:sp>
+      <p:sp>
+        <p:nvSpPr>
+          <p:cNvPr id="10" name="Text 5"/>
+          <p:cNvSpPr/>
+          <p:nvPr/>
+        </p:nvSpPr>
+        <p:spPr>
+          <a:xfrm>
+            <a:off x="566928" y="4517136"/>
+            <a:ext cx="8046720" cy="274320"/>
+          </a:xfrm>
+          <a:prstGeom prst="rect">
+            <a:avLst/>
+          </a:prstGeom>
+          <a:noFill/>
+          <a:ln/>
+        </p:spPr>
+        <p:txBody>
+          <a:bodyPr wrap="square" lIns="0" tIns="0" rIns="0" bIns="0" rtlCol="0" anchor="ctr"/>
+          <a:lstStyle/>
+          <a:p>
+            <a:pPr indent="0" marL="0">
+              <a:buNone/>
+            </a:pPr>
+            <a:r>
+              <a:rPr lang="en-US" sz="1200" i="1" dirty="0">
+                <a:solidFill>
+                  <a:srgbClr val="9AA7B2"/>
+                </a:solidFill>
+                <a:latin typeface="Calibri" pitchFamily="34" charset="0"/>
+                <a:ea typeface="Calibri" pitchFamily="34" charset="-122"/>
+                <a:cs typeface="Calibri" pitchFamily="34" charset="-120"/>
+              </a:rPr>
+              <a:t>Every peso figure on these cards is a real range from the price list.</a:t>
+            </a:r>
+            <a:endParaRPr lang="en-US" sz="1200" dirty="0"/>
           </a:p>
         </p:txBody>
       </p:sp>
@@ -3138,7 +4036,7 @@
     <p:bg>
       <p:bgPr>
         <a:solidFill>
-          <a:srgbClr val="16232E"/>
+          <a:srgbClr val="F6F4EF"/>
         </a:solidFill>
       </p:bgPr>
     </p:bg>
@@ -3158,36 +4056,14 @@
       </p:grpSpPr>
       <p:sp>
         <p:nvSpPr>
-          <p:cNvPr id="2" name="Shape 0"/>
-          <p:cNvSpPr/>
-          <p:nvPr/>
-        </p:nvSpPr>
-        <p:spPr>
-          <a:xfrm>
-            <a:off x="6949440" y="960120"/>
-            <a:ext cx="3108960" cy="3108960"/>
-          </a:xfrm>
-          <a:prstGeom prst="ellipse">
-            <a:avLst/>
-          </a:prstGeom>
-          <a:ln w="15875">
-            <a:solidFill>
-              <a:srgbClr val="C4622D"/>
-            </a:solidFill>
-            <a:prstDash val="solid"/>
-          </a:ln>
-        </p:spPr>
-      </p:sp>
-      <p:sp>
-        <p:nvSpPr>
-          <p:cNvPr id="3" name="Text 1"/>
-          <p:cNvSpPr/>
-          <p:nvPr/>
-        </p:nvSpPr>
-        <p:spPr>
-          <a:xfrm>
-            <a:off x="566928" y="658368"/>
-            <a:ext cx="1097280" cy="365760"/>
+          <p:cNvPr id="2" name="Text 0"/>
+          <p:cNvSpPr/>
+          <p:nvPr/>
+        </p:nvSpPr>
+        <p:spPr>
+          <a:xfrm>
+            <a:off x="566928" y="384048"/>
+            <a:ext cx="5486400" cy="274320"/>
           </a:xfrm>
           <a:prstGeom prst="rect">
             <a:avLst/>
@@ -3203,7 +4079,7 @@
               <a:buNone/>
             </a:pPr>
             <a:r>
-              <a:rPr lang="en-US" sz="1200" b="1" spc="240" kern="0" dirty="0">
+              <a:rPr lang="en-US" sz="1100" b="1" spc="220" kern="0" dirty="0">
                 <a:solidFill>
                   <a:srgbClr val="C4622D"/>
                 </a:solidFill>
@@ -3211,22 +4087,22 @@
                 <a:ea typeface="Calibri" pitchFamily="34" charset="-122"/>
                 <a:cs typeface="Calibri" pitchFamily="34" charset="-120"/>
               </a:rPr>
-              <a:t>04</a:t>
-            </a:r>
-            <a:endParaRPr lang="en-US" sz="1200" dirty="0"/>
-          </a:p>
-        </p:txBody>
-      </p:sp>
-      <p:sp>
-        <p:nvSpPr>
-          <p:cNvPr id="4" name="Text 2"/>
-          <p:cNvSpPr/>
-          <p:nvPr/>
-        </p:nvSpPr>
-        <p:spPr>
-          <a:xfrm>
-            <a:off x="548640" y="1188720"/>
-            <a:ext cx="5852160" cy="731520"/>
+              <a:t>ONE SOURCE, THREE RATIOS</a:t>
+            </a:r>
+            <a:endParaRPr lang="en-US" sz="1100" dirty="0"/>
+          </a:p>
+        </p:txBody>
+      </p:sp>
+      <p:sp>
+        <p:nvSpPr>
+          <p:cNvPr id="3" name="Text 1"/>
+          <p:cNvSpPr/>
+          <p:nvPr/>
+        </p:nvSpPr>
+        <p:spPr>
+          <a:xfrm>
+            <a:off x="548640" y="713232"/>
+            <a:ext cx="8046720" cy="457200"/>
           </a:xfrm>
           <a:prstGeom prst="rect">
             <a:avLst/>
@@ -3242,120 +4118,266 @@
               <a:buNone/>
             </a:pPr>
             <a:r>
-              <a:rPr lang="en-US" sz="4000" b="1" dirty="0">
-                <a:solidFill>
-                  <a:srgbClr val="F6F4EF"/>
+              <a:rPr lang="en-US" sz="2700" b="1" dirty="0">
+                <a:solidFill>
+                  <a:srgbClr val="16232E"/>
                 </a:solidFill>
                 <a:latin typeface="Cambria" pitchFamily="34" charset="0"/>
                 <a:ea typeface="Cambria" pitchFamily="34" charset="-122"/>
                 <a:cs typeface="Cambria" pitchFamily="34" charset="-120"/>
               </a:rPr>
-              <a:t>The follow-up</a:t>
-            </a:r>
-            <a:endParaRPr lang="en-US" sz="4000" dirty="0"/>
-          </a:p>
-        </p:txBody>
-      </p:sp>
-      <p:sp>
-        <p:nvSpPr>
-          <p:cNvPr id="5" name="Text 3"/>
-          <p:cNvSpPr/>
-          <p:nvPr/>
-        </p:nvSpPr>
-        <p:spPr>
-          <a:xfrm>
-            <a:off x="566928" y="2121408"/>
-            <a:ext cx="5486400" cy="914400"/>
-          </a:xfrm>
-          <a:prstGeom prst="rect">
-            <a:avLst/>
-          </a:prstGeom>
-          <a:noFill/>
-          <a:ln/>
-        </p:spPr>
-        <p:txBody>
-          <a:bodyPr wrap="square" lIns="0" tIns="0" rIns="0" bIns="0" rtlCol="0" anchor="ctr"/>
-          <a:lstStyle/>
-          <a:p>
-            <a:pPr indent="0" marL="0">
-              <a:lnSpc>
-                <a:spcPts val="2300"/>
-              </a:lnSpc>
-              <a:buNone/>
-            </a:pPr>
-            <a:r>
-              <a:rPr lang="en-US" sz="1500" dirty="0">
-                <a:solidFill>
-                  <a:srgbClr val="F6F4EF"/>
+              <a:t>Nothing gets a bad crop</a:t>
+            </a:r>
+            <a:endParaRPr lang="en-US" sz="2700" dirty="0"/>
+          </a:p>
+        </p:txBody>
+      </p:sp>
+      <p:pic>
+        <p:nvPicPr>
+          <p:cNvPr id="4" name="Image 0" descr="img/ratio-45.png">    </p:cNvPr>
+          <p:cNvPicPr>
+            <a:picLocks noChangeAspect="1"/>
+          </p:cNvPicPr>
+          <p:nvPr/>
+        </p:nvPicPr>
+        <p:blipFill>
+          <a:blip r:embed="rId1"/>
+          <a:stretch>
+            <a:fillRect/>
+          </a:stretch>
+        </p:blipFill>
+        <p:spPr>
+          <a:xfrm>
+            <a:off x="1133856" y="1572768"/>
+            <a:ext cx="1975104" cy="2468880"/>
+          </a:xfrm>
+          <a:prstGeom prst="rect">
+            <a:avLst/>
+          </a:prstGeom>
+          <a:effectLst>
+            <a:outerShdw sx="100000" sy="100000" kx="0" ky="0" algn="bl" rotWithShape="0" blurRad="127000" dist="25400" dir="5400000">
+              <a:srgbClr val="16232E">
+                <a:alpha val="18000"/>
+              </a:srgbClr>
+            </a:outerShdw>
+          </a:effectLst>
+        </p:spPr>
+      </p:pic>
+      <p:sp>
+        <p:nvSpPr>
+          <p:cNvPr id="5" name="Text 2"/>
+          <p:cNvSpPr/>
+          <p:nvPr/>
+        </p:nvSpPr>
+        <p:spPr>
+          <a:xfrm>
+            <a:off x="859536" y="4151376"/>
+            <a:ext cx="2523744" cy="256032"/>
+          </a:xfrm>
+          <a:prstGeom prst="rect">
+            <a:avLst/>
+          </a:prstGeom>
+          <a:noFill/>
+          <a:ln/>
+        </p:spPr>
+        <p:txBody>
+          <a:bodyPr wrap="square" lIns="0" tIns="0" rIns="0" bIns="0" rtlCol="0" anchor="ctr"/>
+          <a:lstStyle/>
+          <a:p>
+            <a:pPr algn="ctr" indent="0" marL="0">
+              <a:buNone/>
+            </a:pPr>
+            <a:r>
+              <a:rPr lang="en-US" sz="1100" b="1" dirty="0">
+                <a:solidFill>
+                  <a:srgbClr val="2C4356"/>
                 </a:solidFill>
                 <a:latin typeface="Calibri" pitchFamily="34" charset="0"/>
                 <a:ea typeface="Calibri" pitchFamily="34" charset="-122"/>
                 <a:cs typeface="Calibri" pitchFamily="34" charset="-120"/>
               </a:rPr>
-              <a:t>Four workflows. A reply inside sixty seconds, then a sequence that branches on who the lead actually is.</a:t>
-            </a:r>
-            <a:endParaRPr lang="en-US" sz="1500" dirty="0"/>
-          </a:p>
-        </p:txBody>
-      </p:sp>
-      <p:sp>
-        <p:nvSpPr>
-          <p:cNvPr id="6" name="Shape 4"/>
-          <p:cNvSpPr/>
-          <p:nvPr/>
-        </p:nvSpPr>
-        <p:spPr>
-          <a:xfrm>
-            <a:off x="548640" y="3401568"/>
-            <a:ext cx="5669280" cy="713232"/>
-          </a:xfrm>
-          <a:prstGeom prst="roundRect">
-            <a:avLst>
-              <a:gd name="adj" fmla="val 6410"/>
-            </a:avLst>
-          </a:prstGeom>
-          <a:solidFill>
-            <a:srgbClr val="2C4356"/>
-          </a:solidFill>
-          <a:ln/>
-        </p:spPr>
-      </p:sp>
-      <p:sp>
-        <p:nvSpPr>
-          <p:cNvPr id="7" name="Text 5"/>
-          <p:cNvSpPr/>
-          <p:nvPr/>
-        </p:nvSpPr>
-        <p:spPr>
-          <a:xfrm>
-            <a:off x="777240" y="3401568"/>
-            <a:ext cx="5212080" cy="713232"/>
-          </a:xfrm>
-          <a:prstGeom prst="rect">
-            <a:avLst/>
-          </a:prstGeom>
-          <a:noFill/>
-          <a:ln/>
-        </p:spPr>
-        <p:txBody>
-          <a:bodyPr wrap="square" lIns="0" tIns="0" rIns="0" bIns="0" rtlCol="0" anchor="ctr"/>
-          <a:lstStyle/>
-          <a:p>
-            <a:pPr indent="0" marL="0">
-              <a:buNone/>
-            </a:pPr>
-            <a:r>
-              <a:rPr lang="en-US" sz="1350" b="1" dirty="0">
-                <a:solidFill>
-                  <a:srgbClr val="F6F4EF"/>
+              <a:t>4:5 · feed</a:t>
+            </a:r>
+            <a:endParaRPr lang="en-US" sz="1100" dirty="0"/>
+          </a:p>
+        </p:txBody>
+      </p:sp>
+      <p:pic>
+        <p:nvPicPr>
+          <p:cNvPr id="6" name="Image 1" descr="img/ratio-11.png">    </p:cNvPr>
+          <p:cNvPicPr>
+            <a:picLocks noChangeAspect="1"/>
+          </p:cNvPicPr>
+          <p:nvPr/>
+        </p:nvPicPr>
+        <p:blipFill>
+          <a:blip r:embed="rId2"/>
+          <a:stretch>
+            <a:fillRect/>
+          </a:stretch>
+        </p:blipFill>
+        <p:spPr>
+          <a:xfrm>
+            <a:off x="3675888" y="1847088"/>
+            <a:ext cx="2194560" cy="2194560"/>
+          </a:xfrm>
+          <a:prstGeom prst="rect">
+            <a:avLst/>
+          </a:prstGeom>
+          <a:effectLst>
+            <a:outerShdw sx="100000" sy="100000" kx="0" ky="0" algn="bl" rotWithShape="0" blurRad="127000" dist="25400" dir="5400000">
+              <a:srgbClr val="16232E">
+                <a:alpha val="18000"/>
+              </a:srgbClr>
+            </a:outerShdw>
+          </a:effectLst>
+        </p:spPr>
+      </p:pic>
+      <p:sp>
+        <p:nvSpPr>
+          <p:cNvPr id="7" name="Text 3"/>
+          <p:cNvSpPr/>
+          <p:nvPr/>
+        </p:nvSpPr>
+        <p:spPr>
+          <a:xfrm>
+            <a:off x="3401568" y="4151376"/>
+            <a:ext cx="2743200" cy="256032"/>
+          </a:xfrm>
+          <a:prstGeom prst="rect">
+            <a:avLst/>
+          </a:prstGeom>
+          <a:noFill/>
+          <a:ln/>
+        </p:spPr>
+        <p:txBody>
+          <a:bodyPr wrap="square" lIns="0" tIns="0" rIns="0" bIns="0" rtlCol="0" anchor="ctr"/>
+          <a:lstStyle/>
+          <a:p>
+            <a:pPr algn="ctr" indent="0" marL="0">
+              <a:buNone/>
+            </a:pPr>
+            <a:r>
+              <a:rPr lang="en-US" sz="1100" b="1" dirty="0">
+                <a:solidFill>
+                  <a:srgbClr val="2C4356"/>
                 </a:solidFill>
                 <a:latin typeface="Calibri" pitchFamily="34" charset="0"/>
                 <a:ea typeface="Calibri" pitchFamily="34" charset="-122"/>
                 <a:cs typeface="Calibri" pitchFamily="34" charset="-120"/>
               </a:rPr>
-              <a:t>What I can build for you: the part that runs when nobody is at their desk.</a:t>
-            </a:r>
-            <a:endParaRPr lang="en-US" sz="1350" dirty="0"/>
+              <a:t>1:1 · carousel card</a:t>
+            </a:r>
+            <a:endParaRPr lang="en-US" sz="1100" dirty="0"/>
+          </a:p>
+        </p:txBody>
+      </p:sp>
+      <p:pic>
+        <p:nvPicPr>
+          <p:cNvPr id="8" name="Image 2" descr="img/ratio-916.png">    </p:cNvPr>
+          <p:cNvPicPr>
+            <a:picLocks noChangeAspect="1"/>
+          </p:cNvPicPr>
+          <p:nvPr/>
+        </p:nvPicPr>
+        <p:blipFill>
+          <a:blip r:embed="rId3"/>
+          <a:stretch>
+            <a:fillRect/>
+          </a:stretch>
+        </p:blipFill>
+        <p:spPr>
+          <a:xfrm>
+            <a:off x="6437376" y="1252728"/>
+            <a:ext cx="1572768" cy="2788920"/>
+          </a:xfrm>
+          <a:prstGeom prst="rect">
+            <a:avLst/>
+          </a:prstGeom>
+          <a:effectLst>
+            <a:outerShdw sx="100000" sy="100000" kx="0" ky="0" algn="bl" rotWithShape="0" blurRad="127000" dist="25400" dir="5400000">
+              <a:srgbClr val="16232E">
+                <a:alpha val="18000"/>
+              </a:srgbClr>
+            </a:outerShdw>
+          </a:effectLst>
+        </p:spPr>
+      </p:pic>
+      <p:sp>
+        <p:nvSpPr>
+          <p:cNvPr id="9" name="Text 4"/>
+          <p:cNvSpPr/>
+          <p:nvPr/>
+        </p:nvSpPr>
+        <p:spPr>
+          <a:xfrm>
+            <a:off x="6163056" y="4151376"/>
+            <a:ext cx="2121408" cy="256032"/>
+          </a:xfrm>
+          <a:prstGeom prst="rect">
+            <a:avLst/>
+          </a:prstGeom>
+          <a:noFill/>
+          <a:ln/>
+        </p:spPr>
+        <p:txBody>
+          <a:bodyPr wrap="square" lIns="0" tIns="0" rIns="0" bIns="0" rtlCol="0" anchor="ctr"/>
+          <a:lstStyle/>
+          <a:p>
+            <a:pPr algn="ctr" indent="0" marL="0">
+              <a:buNone/>
+            </a:pPr>
+            <a:r>
+              <a:rPr lang="en-US" sz="1100" b="1" dirty="0">
+                <a:solidFill>
+                  <a:srgbClr val="2C4356"/>
+                </a:solidFill>
+                <a:latin typeface="Calibri" pitchFamily="34" charset="0"/>
+                <a:ea typeface="Calibri" pitchFamily="34" charset="-122"/>
+                <a:cs typeface="Calibri" pitchFamily="34" charset="-120"/>
+              </a:rPr>
+              <a:t>9:16 · Stories and Reels</a:t>
+            </a:r>
+            <a:endParaRPr lang="en-US" sz="1100" dirty="0"/>
+          </a:p>
+        </p:txBody>
+      </p:sp>
+      <p:sp>
+        <p:nvSpPr>
+          <p:cNvPr id="10" name="Text 5"/>
+          <p:cNvSpPr/>
+          <p:nvPr/>
+        </p:nvSpPr>
+        <p:spPr>
+          <a:xfrm>
+            <a:off x="548640" y="4517136"/>
+            <a:ext cx="8046720" cy="274320"/>
+          </a:xfrm>
+          <a:prstGeom prst="rect">
+            <a:avLst/>
+          </a:prstGeom>
+          <a:noFill/>
+          <a:ln/>
+        </p:spPr>
+        <p:txBody>
+          <a:bodyPr wrap="square" lIns="0" tIns="0" rIns="0" bIns="0" rtlCol="0" anchor="ctr"/>
+          <a:lstStyle/>
+          <a:p>
+            <a:pPr algn="ctr" indent="0" marL="0">
+              <a:buNone/>
+            </a:pPr>
+            <a:r>
+              <a:rPr lang="en-US" sz="1200" i="1" dirty="0">
+                <a:solidFill>
+                  <a:srgbClr val="2C4356"/>
+                </a:solidFill>
+                <a:latin typeface="Calibri" pitchFamily="34" charset="0"/>
+                <a:ea typeface="Calibri" pitchFamily="34" charset="-122"/>
+                <a:cs typeface="Calibri" pitchFamily="34" charset="-120"/>
+              </a:rPr>
+              <a:t>Same HTML source, three viewport-height media queries. Fix a typo once, re-render three times.</a:t>
+            </a:r>
+            <a:endParaRPr lang="en-US" sz="1200" dirty="0"/>
           </a:p>
         </p:txBody>
       </p:sp>
@@ -3399,8 +4421,727 @@
         </p:nvSpPr>
         <p:spPr>
           <a:xfrm>
-            <a:off x="-1005840" y="2286000"/>
-            <a:ext cx="3291840" cy="3291840"/>
+            <a:off x="7315200" y="3017520"/>
+            <a:ext cx="2377440" cy="2377440"/>
+          </a:xfrm>
+          <a:prstGeom prst="ellipse">
+            <a:avLst/>
+          </a:prstGeom>
+          <a:ln w="12700">
+            <a:solidFill>
+              <a:srgbClr val="C4622D"/>
+            </a:solidFill>
+            <a:prstDash val="solid"/>
+          </a:ln>
+        </p:spPr>
+      </p:sp>
+      <p:sp>
+        <p:nvSpPr>
+          <p:cNvPr id="3" name="Text 1"/>
+          <p:cNvSpPr/>
+          <p:nvPr/>
+        </p:nvSpPr>
+        <p:spPr>
+          <a:xfrm>
+            <a:off x="566928" y="384048"/>
+            <a:ext cx="5486400" cy="274320"/>
+          </a:xfrm>
+          <a:prstGeom prst="rect">
+            <a:avLst/>
+          </a:prstGeom>
+          <a:noFill/>
+          <a:ln/>
+        </p:spPr>
+        <p:txBody>
+          <a:bodyPr wrap="square" lIns="0" tIns="0" rIns="0" bIns="0" rtlCol="0" anchor="ctr"/>
+          <a:lstStyle/>
+          <a:p>
+            <a:pPr indent="0" marL="0">
+              <a:buNone/>
+            </a:pPr>
+            <a:r>
+              <a:rPr lang="en-US" sz="1100" b="1" spc="220" kern="0" dirty="0">
+                <a:solidFill>
+                  <a:srgbClr val="C4622D"/>
+                </a:solidFill>
+                <a:latin typeface="Calibri" pitchFamily="34" charset="0"/>
+                <a:ea typeface="Calibri" pitchFamily="34" charset="-122"/>
+                <a:cs typeface="Calibri" pitchFamily="34" charset="-120"/>
+              </a:rPr>
+              <a:t>FOUR ADS, ONE TEST</a:t>
+            </a:r>
+            <a:endParaRPr lang="en-US" sz="1100" dirty="0"/>
+          </a:p>
+        </p:txBody>
+      </p:sp>
+      <p:sp>
+        <p:nvSpPr>
+          <p:cNvPr id="4" name="Text 2"/>
+          <p:cNvSpPr/>
+          <p:nvPr/>
+        </p:nvSpPr>
+        <p:spPr>
+          <a:xfrm>
+            <a:off x="548640" y="713232"/>
+            <a:ext cx="8046720" cy="457200"/>
+          </a:xfrm>
+          <a:prstGeom prst="rect">
+            <a:avLst/>
+          </a:prstGeom>
+          <a:noFill/>
+          <a:ln/>
+        </p:spPr>
+        <p:txBody>
+          <a:bodyPr wrap="square" lIns="0" tIns="0" rIns="0" bIns="0" rtlCol="0" anchor="ctr"/>
+          <a:lstStyle/>
+          <a:p>
+            <a:pPr indent="0" marL="0">
+              <a:buNone/>
+            </a:pPr>
+            <a:r>
+              <a:rPr lang="en-US" sz="2700" b="1" dirty="0">
+                <a:solidFill>
+                  <a:srgbClr val="F6F4EF"/>
+                </a:solidFill>
+                <a:latin typeface="Cambria" pitchFamily="34" charset="0"/>
+                <a:ea typeface="Cambria" pitchFamily="34" charset="-122"/>
+                <a:cs typeface="Cambria" pitchFamily="34" charset="-120"/>
+              </a:rPr>
+              <a:t>Written so the result means something</a:t>
+            </a:r>
+            <a:endParaRPr lang="en-US" sz="2700" dirty="0"/>
+          </a:p>
+        </p:txBody>
+      </p:sp>
+      <p:sp>
+        <p:nvSpPr>
+          <p:cNvPr id="5" name="Shape 3"/>
+          <p:cNvSpPr/>
+          <p:nvPr/>
+        </p:nvSpPr>
+        <p:spPr>
+          <a:xfrm>
+            <a:off x="603504" y="1508760"/>
+            <a:ext cx="365760" cy="365760"/>
+          </a:xfrm>
+          <a:prstGeom prst="ellipse">
+            <a:avLst/>
+          </a:prstGeom>
+          <a:solidFill>
+            <a:srgbClr val="C4622D"/>
+          </a:solidFill>
+          <a:ln/>
+        </p:spPr>
+      </p:sp>
+      <p:sp>
+        <p:nvSpPr>
+          <p:cNvPr id="6" name="Text 4"/>
+          <p:cNvSpPr/>
+          <p:nvPr/>
+        </p:nvSpPr>
+        <p:spPr>
+          <a:xfrm>
+            <a:off x="603504" y="1508760"/>
+            <a:ext cx="365760" cy="365760"/>
+          </a:xfrm>
+          <a:prstGeom prst="rect">
+            <a:avLst/>
+          </a:prstGeom>
+          <a:noFill/>
+          <a:ln/>
+        </p:spPr>
+        <p:txBody>
+          <a:bodyPr wrap="square" lIns="0" tIns="0" rIns="0" bIns="0" rtlCol="0" anchor="ctr"/>
+          <a:lstStyle/>
+          <a:p>
+            <a:pPr algn="ctr" indent="0" marL="0">
+              <a:buNone/>
+            </a:pPr>
+            <a:r>
+              <a:rPr lang="en-US" sz="1500" b="1" dirty="0">
+                <a:solidFill>
+                  <a:srgbClr val="F6F4EF"/>
+                </a:solidFill>
+                <a:latin typeface="Cambria" pitchFamily="34" charset="0"/>
+                <a:ea typeface="Cambria" pitchFamily="34" charset="-122"/>
+                <a:cs typeface="Cambria" pitchFamily="34" charset="-120"/>
+              </a:rPr>
+              <a:t>1</a:t>
+            </a:r>
+            <a:endParaRPr lang="en-US" sz="1500" dirty="0"/>
+          </a:p>
+        </p:txBody>
+      </p:sp>
+      <p:sp>
+        <p:nvSpPr>
+          <p:cNvPr id="7" name="Text 5"/>
+          <p:cNvSpPr/>
+          <p:nvPr/>
+        </p:nvSpPr>
+        <p:spPr>
+          <a:xfrm>
+            <a:off x="1133856" y="1444752"/>
+            <a:ext cx="2651760" cy="274320"/>
+          </a:xfrm>
+          <a:prstGeom prst="rect">
+            <a:avLst/>
+          </a:prstGeom>
+          <a:noFill/>
+          <a:ln/>
+        </p:spPr>
+        <p:txBody>
+          <a:bodyPr wrap="square" lIns="0" tIns="0" rIns="0" bIns="0" rtlCol="0" anchor="ctr"/>
+          <a:lstStyle/>
+          <a:p>
+            <a:pPr indent="0" marL="0">
+              <a:buNone/>
+            </a:pPr>
+            <a:r>
+              <a:rPr lang="en-US" sz="1350" b="1" dirty="0">
+                <a:solidFill>
+                  <a:srgbClr val="C4622D"/>
+                </a:solidFill>
+                <a:latin typeface="Calibri" pitchFamily="34" charset="0"/>
+                <a:ea typeface="Calibri" pitchFamily="34" charset="-122"/>
+                <a:cs typeface="Calibri" pitchFamily="34" charset="-120"/>
+              </a:rPr>
+              <a:t>six-signs-carousel</a:t>
+            </a:r>
+            <a:endParaRPr lang="en-US" sz="1350" dirty="0"/>
+          </a:p>
+        </p:txBody>
+      </p:sp>
+      <p:sp>
+        <p:nvSpPr>
+          <p:cNvPr id="8" name="Text 6"/>
+          <p:cNvSpPr/>
+          <p:nvPr/>
+        </p:nvSpPr>
+        <p:spPr>
+          <a:xfrm>
+            <a:off x="1133856" y="1682496"/>
+            <a:ext cx="5852160" cy="274320"/>
+          </a:xfrm>
+          <a:prstGeom prst="rect">
+            <a:avLst/>
+          </a:prstGeom>
+          <a:noFill/>
+          <a:ln/>
+        </p:spPr>
+        <p:txBody>
+          <a:bodyPr wrap="square" lIns="0" tIns="0" rIns="0" bIns="0" rtlCol="0" anchor="ctr"/>
+          <a:lstStyle/>
+          <a:p>
+            <a:pPr indent="0" marL="0">
+              <a:buNone/>
+            </a:pPr>
+            <a:r>
+              <a:rPr lang="en-US" sz="1300" dirty="0">
+                <a:solidFill>
+                  <a:srgbClr val="F6F4EF"/>
+                </a:solidFill>
+                <a:latin typeface="Calibri" pitchFamily="34" charset="0"/>
+                <a:ea typeface="Calibri" pitchFamily="34" charset="-122"/>
+                <a:cs typeface="Calibri" pitchFamily="34" charset="-120"/>
+              </a:rPr>
+              <a:t>The full educational sequence</a:t>
+            </a:r>
+            <a:endParaRPr lang="en-US" sz="1300" dirty="0"/>
+          </a:p>
+        </p:txBody>
+      </p:sp>
+      <p:sp>
+        <p:nvSpPr>
+          <p:cNvPr id="9" name="Shape 7"/>
+          <p:cNvSpPr/>
+          <p:nvPr/>
+        </p:nvSpPr>
+        <p:spPr>
+          <a:xfrm>
+            <a:off x="603504" y="2167128"/>
+            <a:ext cx="365760" cy="365760"/>
+          </a:xfrm>
+          <a:prstGeom prst="ellipse">
+            <a:avLst/>
+          </a:prstGeom>
+          <a:solidFill>
+            <a:srgbClr val="C4622D"/>
+          </a:solidFill>
+          <a:ln/>
+        </p:spPr>
+      </p:sp>
+      <p:sp>
+        <p:nvSpPr>
+          <p:cNvPr id="10" name="Text 8"/>
+          <p:cNvSpPr/>
+          <p:nvPr/>
+        </p:nvSpPr>
+        <p:spPr>
+          <a:xfrm>
+            <a:off x="603504" y="2167128"/>
+            <a:ext cx="365760" cy="365760"/>
+          </a:xfrm>
+          <a:prstGeom prst="rect">
+            <a:avLst/>
+          </a:prstGeom>
+          <a:noFill/>
+          <a:ln/>
+        </p:spPr>
+        <p:txBody>
+          <a:bodyPr wrap="square" lIns="0" tIns="0" rIns="0" bIns="0" rtlCol="0" anchor="ctr"/>
+          <a:lstStyle/>
+          <a:p>
+            <a:pPr algn="ctr" indent="0" marL="0">
+              <a:buNone/>
+            </a:pPr>
+            <a:r>
+              <a:rPr lang="en-US" sz="1500" b="1" dirty="0">
+                <a:solidFill>
+                  <a:srgbClr val="F6F4EF"/>
+                </a:solidFill>
+                <a:latin typeface="Cambria" pitchFamily="34" charset="0"/>
+                <a:ea typeface="Cambria" pitchFamily="34" charset="-122"/>
+                <a:cs typeface="Cambria" pitchFamily="34" charset="-120"/>
+              </a:rPr>
+              <a:t>2</a:t>
+            </a:r>
+            <a:endParaRPr lang="en-US" sz="1500" dirty="0"/>
+          </a:p>
+        </p:txBody>
+      </p:sp>
+      <p:sp>
+        <p:nvSpPr>
+          <p:cNvPr id="11" name="Text 9"/>
+          <p:cNvSpPr/>
+          <p:nvPr/>
+        </p:nvSpPr>
+        <p:spPr>
+          <a:xfrm>
+            <a:off x="1133856" y="2103120"/>
+            <a:ext cx="2651760" cy="274320"/>
+          </a:xfrm>
+          <a:prstGeom prst="rect">
+            <a:avLst/>
+          </a:prstGeom>
+          <a:noFill/>
+          <a:ln/>
+        </p:spPr>
+        <p:txBody>
+          <a:bodyPr wrap="square" lIns="0" tIns="0" rIns="0" bIns="0" rtlCol="0" anchor="ctr"/>
+          <a:lstStyle/>
+          <a:p>
+            <a:pPr indent="0" marL="0">
+              <a:buNone/>
+            </a:pPr>
+            <a:r>
+              <a:rPr lang="en-US" sz="1350" b="1" dirty="0">
+                <a:solidFill>
+                  <a:srgbClr val="C4622D"/>
+                </a:solidFill>
+                <a:latin typeface="Calibri" pitchFamily="34" charset="0"/>
+                <a:ea typeface="Calibri" pitchFamily="34" charset="-122"/>
+                <a:cs typeface="Calibri" pitchFamily="34" charset="-120"/>
+              </a:rPr>
+              <a:t>story-7800</a:t>
+            </a:r>
+            <a:endParaRPr lang="en-US" sz="1350" dirty="0"/>
+          </a:p>
+        </p:txBody>
+      </p:sp>
+      <p:sp>
+        <p:nvSpPr>
+          <p:cNvPr id="12" name="Text 10"/>
+          <p:cNvSpPr/>
+          <p:nvPr/>
+        </p:nvSpPr>
+        <p:spPr>
+          <a:xfrm>
+            <a:off x="1133856" y="2340864"/>
+            <a:ext cx="5852160" cy="274320"/>
+          </a:xfrm>
+          <a:prstGeom prst="rect">
+            <a:avLst/>
+          </a:prstGeom>
+          <a:noFill/>
+          <a:ln/>
+        </p:spPr>
+        <p:txBody>
+          <a:bodyPr wrap="square" lIns="0" tIns="0" rIns="0" bIns="0" rtlCol="0" anchor="ctr"/>
+          <a:lstStyle/>
+          <a:p>
+            <a:pPr indent="0" marL="0">
+              <a:buNone/>
+            </a:pPr>
+            <a:r>
+              <a:rPr lang="en-US" sz="1300" dirty="0">
+                <a:solidFill>
+                  <a:srgbClr val="F6F4EF"/>
+                </a:solidFill>
+                <a:latin typeface="Calibri" pitchFamily="34" charset="0"/>
+                <a:ea typeface="Calibri" pitchFamily="34" charset="-122"/>
+                <a:cs typeface="Calibri" pitchFamily="34" charset="-120"/>
+              </a:rPr>
+              <a:t>Photo · English testimonial</a:t>
+            </a:r>
+            <a:endParaRPr lang="en-US" sz="1300" dirty="0"/>
+          </a:p>
+        </p:txBody>
+      </p:sp>
+      <p:sp>
+        <p:nvSpPr>
+          <p:cNvPr id="13" name="Shape 11"/>
+          <p:cNvSpPr/>
+          <p:nvPr/>
+        </p:nvSpPr>
+        <p:spPr>
+          <a:xfrm>
+            <a:off x="603504" y="2825496"/>
+            <a:ext cx="365760" cy="365760"/>
+          </a:xfrm>
+          <a:prstGeom prst="ellipse">
+            <a:avLst/>
+          </a:prstGeom>
+          <a:solidFill>
+            <a:srgbClr val="C4622D"/>
+          </a:solidFill>
+          <a:ln/>
+        </p:spPr>
+      </p:sp>
+      <p:sp>
+        <p:nvSpPr>
+          <p:cNvPr id="14" name="Text 12"/>
+          <p:cNvSpPr/>
+          <p:nvPr/>
+        </p:nvSpPr>
+        <p:spPr>
+          <a:xfrm>
+            <a:off x="603504" y="2825496"/>
+            <a:ext cx="365760" cy="365760"/>
+          </a:xfrm>
+          <a:prstGeom prst="rect">
+            <a:avLst/>
+          </a:prstGeom>
+          <a:noFill/>
+          <a:ln/>
+        </p:spPr>
+        <p:txBody>
+          <a:bodyPr wrap="square" lIns="0" tIns="0" rIns="0" bIns="0" rtlCol="0" anchor="ctr"/>
+          <a:lstStyle/>
+          <a:p>
+            <a:pPr algn="ctr" indent="0" marL="0">
+              <a:buNone/>
+            </a:pPr>
+            <a:r>
+              <a:rPr lang="en-US" sz="1500" b="1" dirty="0">
+                <a:solidFill>
+                  <a:srgbClr val="F6F4EF"/>
+                </a:solidFill>
+                <a:latin typeface="Cambria" pitchFamily="34" charset="0"/>
+                <a:ea typeface="Cambria" pitchFamily="34" charset="-122"/>
+                <a:cs typeface="Cambria" pitchFamily="34" charset="-120"/>
+              </a:rPr>
+              <a:t>3</a:t>
+            </a:r>
+            <a:endParaRPr lang="en-US" sz="1500" dirty="0"/>
+          </a:p>
+        </p:txBody>
+      </p:sp>
+      <p:sp>
+        <p:nvSpPr>
+          <p:cNvPr id="15" name="Text 13"/>
+          <p:cNvSpPr/>
+          <p:nvPr/>
+        </p:nvSpPr>
+        <p:spPr>
+          <a:xfrm>
+            <a:off x="1133856" y="2761488"/>
+            <a:ext cx="2651760" cy="274320"/>
+          </a:xfrm>
+          <a:prstGeom prst="rect">
+            <a:avLst/>
+          </a:prstGeom>
+          <a:noFill/>
+          <a:ln/>
+        </p:spPr>
+        <p:txBody>
+          <a:bodyPr wrap="square" lIns="0" tIns="0" rIns="0" bIns="0" rtlCol="0" anchor="ctr"/>
+          <a:lstStyle/>
+          <a:p>
+            <a:pPr indent="0" marL="0">
+              <a:buNone/>
+            </a:pPr>
+            <a:r>
+              <a:rPr lang="en-US" sz="1350" b="1" dirty="0">
+                <a:solidFill>
+                  <a:srgbClr val="C4622D"/>
+                </a:solidFill>
+                <a:latin typeface="Calibri" pitchFamily="34" charset="0"/>
+                <a:ea typeface="Calibri" pitchFamily="34" charset="-122"/>
+                <a:cs typeface="Calibri" pitchFamily="34" charset="-120"/>
+              </a:rPr>
+              <a:t>taglish-380k</a:t>
+            </a:r>
+            <a:endParaRPr lang="en-US" sz="1350" dirty="0"/>
+          </a:p>
+        </p:txBody>
+      </p:sp>
+      <p:sp>
+        <p:nvSpPr>
+          <p:cNvPr id="16" name="Text 14"/>
+          <p:cNvSpPr/>
+          <p:nvPr/>
+        </p:nvSpPr>
+        <p:spPr>
+          <a:xfrm>
+            <a:off x="1133856" y="2999232"/>
+            <a:ext cx="5852160" cy="274320"/>
+          </a:xfrm>
+          <a:prstGeom prst="rect">
+            <a:avLst/>
+          </a:prstGeom>
+          <a:noFill/>
+          <a:ln/>
+        </p:spPr>
+        <p:txBody>
+          <a:bodyPr wrap="square" lIns="0" tIns="0" rIns="0" bIns="0" rtlCol="0" anchor="ctr"/>
+          <a:lstStyle/>
+          <a:p>
+            <a:pPr indent="0" marL="0">
+              <a:buNone/>
+            </a:pPr>
+            <a:r>
+              <a:rPr lang="en-US" sz="1300" dirty="0">
+                <a:solidFill>
+                  <a:srgbClr val="F6F4EF"/>
+                </a:solidFill>
+                <a:latin typeface="Calibri" pitchFamily="34" charset="0"/>
+                <a:ea typeface="Calibri" pitchFamily="34" charset="-122"/>
+                <a:cs typeface="Calibri" pitchFamily="34" charset="-120"/>
+              </a:rPr>
+              <a:t>Same creative, Taglish interrupt — isolates copy</a:t>
+            </a:r>
+            <a:endParaRPr lang="en-US" sz="1300" dirty="0"/>
+          </a:p>
+        </p:txBody>
+      </p:sp>
+      <p:sp>
+        <p:nvSpPr>
+          <p:cNvPr id="17" name="Shape 15"/>
+          <p:cNvSpPr/>
+          <p:nvPr/>
+        </p:nvSpPr>
+        <p:spPr>
+          <a:xfrm>
+            <a:off x="603504" y="3483864"/>
+            <a:ext cx="365760" cy="365760"/>
+          </a:xfrm>
+          <a:prstGeom prst="ellipse">
+            <a:avLst/>
+          </a:prstGeom>
+          <a:solidFill>
+            <a:srgbClr val="C4622D"/>
+          </a:solidFill>
+          <a:ln/>
+        </p:spPr>
+      </p:sp>
+      <p:sp>
+        <p:nvSpPr>
+          <p:cNvPr id="18" name="Text 16"/>
+          <p:cNvSpPr/>
+          <p:nvPr/>
+        </p:nvSpPr>
+        <p:spPr>
+          <a:xfrm>
+            <a:off x="603504" y="3483864"/>
+            <a:ext cx="365760" cy="365760"/>
+          </a:xfrm>
+          <a:prstGeom prst="rect">
+            <a:avLst/>
+          </a:prstGeom>
+          <a:noFill/>
+          <a:ln/>
+        </p:spPr>
+        <p:txBody>
+          <a:bodyPr wrap="square" lIns="0" tIns="0" rIns="0" bIns="0" rtlCol="0" anchor="ctr"/>
+          <a:lstStyle/>
+          <a:p>
+            <a:pPr algn="ctr" indent="0" marL="0">
+              <a:buNone/>
+            </a:pPr>
+            <a:r>
+              <a:rPr lang="en-US" sz="1500" b="1" dirty="0">
+                <a:solidFill>
+                  <a:srgbClr val="F6F4EF"/>
+                </a:solidFill>
+                <a:latin typeface="Cambria" pitchFamily="34" charset="0"/>
+                <a:ea typeface="Cambria" pitchFamily="34" charset="-122"/>
+                <a:cs typeface="Cambria" pitchFamily="34" charset="-120"/>
+              </a:rPr>
+              <a:t>4</a:t>
+            </a:r>
+            <a:endParaRPr lang="en-US" sz="1500" dirty="0"/>
+          </a:p>
+        </p:txBody>
+      </p:sp>
+      <p:sp>
+        <p:nvSpPr>
+          <p:cNvPr id="19" name="Text 17"/>
+          <p:cNvSpPr/>
+          <p:nvPr/>
+        </p:nvSpPr>
+        <p:spPr>
+          <a:xfrm>
+            <a:off x="1133856" y="3419856"/>
+            <a:ext cx="2651760" cy="274320"/>
+          </a:xfrm>
+          <a:prstGeom prst="rect">
+            <a:avLst/>
+          </a:prstGeom>
+          <a:noFill/>
+          <a:ln/>
+        </p:spPr>
+        <p:txBody>
+          <a:bodyPr wrap="square" lIns="0" tIns="0" rIns="0" bIns="0" rtlCol="0" anchor="ctr"/>
+          <a:lstStyle/>
+          <a:p>
+            <a:pPr indent="0" marL="0">
+              <a:buNone/>
+            </a:pPr>
+            <a:r>
+              <a:rPr lang="en-US" sz="1350" b="1" dirty="0">
+                <a:solidFill>
+                  <a:srgbClr val="C4622D"/>
+                </a:solidFill>
+                <a:latin typeface="Calibri" pitchFamily="34" charset="0"/>
+                <a:ea typeface="Calibri" pitchFamily="34" charset="-122"/>
+                <a:cs typeface="Calibri" pitchFamily="34" charset="-120"/>
+              </a:rPr>
+              <a:t>the-18-peso-part</a:t>
+            </a:r>
+            <a:endParaRPr lang="en-US" sz="1350" dirty="0"/>
+          </a:p>
+        </p:txBody>
+      </p:sp>
+      <p:sp>
+        <p:nvSpPr>
+          <p:cNvPr id="20" name="Text 18"/>
+          <p:cNvSpPr/>
+          <p:nvPr/>
+        </p:nvSpPr>
+        <p:spPr>
+          <a:xfrm>
+            <a:off x="1133856" y="3657600"/>
+            <a:ext cx="5852160" cy="274320"/>
+          </a:xfrm>
+          <a:prstGeom prst="rect">
+            <a:avLst/>
+          </a:prstGeom>
+          <a:noFill/>
+          <a:ln/>
+        </p:spPr>
+        <p:txBody>
+          <a:bodyPr wrap="square" lIns="0" tIns="0" rIns="0" bIns="0" rtlCol="0" anchor="ctr"/>
+          <a:lstStyle/>
+          <a:p>
+            <a:pPr indent="0" marL="0">
+              <a:buNone/>
+            </a:pPr>
+            <a:r>
+              <a:rPr lang="en-US" sz="1300" dirty="0">
+                <a:solidFill>
+                  <a:srgbClr val="F6F4EF"/>
+                </a:solidFill>
+                <a:latin typeface="Calibri" pitchFamily="34" charset="0"/>
+                <a:ea typeface="Calibri" pitchFamily="34" charset="-122"/>
+                <a:cs typeface="Calibri" pitchFamily="34" charset="-120"/>
+              </a:rPr>
+              <a:t>Diagram instead of photo — isolates creative</a:t>
+            </a:r>
+            <a:endParaRPr lang="en-US" sz="1300" dirty="0"/>
+          </a:p>
+        </p:txBody>
+      </p:sp>
+      <p:sp>
+        <p:nvSpPr>
+          <p:cNvPr id="21" name="Text 19"/>
+          <p:cNvSpPr/>
+          <p:nvPr/>
+        </p:nvSpPr>
+        <p:spPr>
+          <a:xfrm>
+            <a:off x="566928" y="4315968"/>
+            <a:ext cx="8046720" cy="320040"/>
+          </a:xfrm>
+          <a:prstGeom prst="rect">
+            <a:avLst/>
+          </a:prstGeom>
+          <a:noFill/>
+          <a:ln/>
+        </p:spPr>
+        <p:txBody>
+          <a:bodyPr wrap="square" lIns="0" tIns="0" rIns="0" bIns="0" rtlCol="0" anchor="ctr"/>
+          <a:lstStyle/>
+          <a:p>
+            <a:pPr indent="0" marL="0">
+              <a:buNone/>
+            </a:pPr>
+            <a:r>
+              <a:rPr lang="en-US" sz="1300" i="1" dirty="0">
+                <a:solidFill>
+                  <a:srgbClr val="9AA7B2"/>
+                </a:solidFill>
+                <a:latin typeface="Calibri" pitchFamily="34" charset="0"/>
+                <a:ea typeface="Calibri" pitchFamily="34" charset="-122"/>
+                <a:cs typeface="Calibri" pitchFamily="34" charset="-120"/>
+              </a:rPr>
+              <a:t>Two pairs, one variable each. Four ads that can actually tell you why one won.</a:t>
+            </a:r>
+            <a:endParaRPr lang="en-US" sz="1300" dirty="0"/>
+          </a:p>
+        </p:txBody>
+      </p:sp>
+    </p:spTree>
+  </p:cSld>
+  <p:clrMapOvr>
+    <a:masterClrMapping/>
+  </p:clrMapOvr>
+</p:sld>
+</file>
+
+<file path=ppt/slides/slide8.xml><?xml version="1.0" encoding="utf-8"?>
+<p:sld xmlns:a="http://schemas.openxmlformats.org/drawingml/2006/main" xmlns:r="http://schemas.openxmlformats.org/officeDocument/2006/relationships" xmlns:p="http://schemas.openxmlformats.org/presentationml/2006/main">
+  <p:cSld name="Slide 8">
+    <p:bg>
+      <p:bgPr>
+        <a:solidFill>
+          <a:srgbClr val="16232E"/>
+        </a:solidFill>
+      </p:bgPr>
+    </p:bg>
+    <p:spTree>
+      <p:nvGrpSpPr>
+        <p:cNvPr id="1" name=""/>
+        <p:cNvGrpSpPr/>
+        <p:nvPr/>
+      </p:nvGrpSpPr>
+      <p:grpSpPr>
+        <a:xfrm>
+          <a:off x="0" y="0"/>
+          <a:ext cx="0" cy="0"/>
+          <a:chOff x="0" y="0"/>
+          <a:chExt cx="0" cy="0"/>
+        </a:xfrm>
+      </p:grpSpPr>
+      <p:sp>
+        <p:nvSpPr>
+          <p:cNvPr id="2" name="Shape 0"/>
+          <p:cNvSpPr/>
+          <p:nvPr/>
+        </p:nvSpPr>
+        <p:spPr>
+          <a:xfrm>
+            <a:off x="6949440" y="960120"/>
+            <a:ext cx="3108960" cy="3108960"/>
           </a:xfrm>
           <a:prstGeom prst="ellipse">
             <a:avLst/>
@@ -3421,8 +5162,8 @@
         </p:nvSpPr>
         <p:spPr>
           <a:xfrm>
-            <a:off x="548640" y="658368"/>
-            <a:ext cx="8046720" cy="365760"/>
+            <a:off x="566928" y="658368"/>
+            <a:ext cx="1097280" cy="365760"/>
           </a:xfrm>
           <a:prstGeom prst="rect">
             <a:avLst/>
@@ -3438,7 +5179,7 @@
               <a:buNone/>
             </a:pPr>
             <a:r>
-              <a:rPr lang="en-US" sz="1200" b="1" spc="220" kern="0" dirty="0">
+              <a:rPr lang="en-US" sz="1200" b="1" spc="240" kern="0" dirty="0">
                 <a:solidFill>
                   <a:srgbClr val="C4622D"/>
                 </a:solidFill>
@@ -3446,7 +5187,7 @@
                 <a:ea typeface="Calibri" pitchFamily="34" charset="-122"/>
                 <a:cs typeface="Calibri" pitchFamily="34" charset="-120"/>
               </a:rPr>
-              <a:t>If you are running the business</a:t>
+              <a:t>03</a:t>
             </a:r>
             <a:endParaRPr lang="en-US" sz="1200" dirty="0"/>
           </a:p>
@@ -3460,8 +5201,8 @@
         </p:nvSpPr>
         <p:spPr>
           <a:xfrm>
-            <a:off x="530352" y="1115568"/>
-            <a:ext cx="8046720" cy="731520"/>
+            <a:off x="548640" y="1188720"/>
+            <a:ext cx="5852160" cy="731520"/>
           </a:xfrm>
           <a:prstGeom prst="rect">
             <a:avLst/>
@@ -3485,7 +5226,7 @@
                 <a:ea typeface="Cambria" pitchFamily="34" charset="-122"/>
                 <a:cs typeface="Cambria" pitchFamily="34" charset="-120"/>
               </a:rPr>
-              <a:t>I can build this for you.</a:t>
+              <a:t>The CRM</a:t>
             </a:r>
             <a:endParaRPr lang="en-US" sz="4000" dirty="0"/>
           </a:p>
@@ -3493,34 +5234,14 @@
       </p:sp>
       <p:sp>
         <p:nvSpPr>
-          <p:cNvPr id="5" name="Shape 3"/>
-          <p:cNvSpPr/>
-          <p:nvPr/>
-        </p:nvSpPr>
-        <p:spPr>
-          <a:xfrm>
-            <a:off x="603504" y="2176272"/>
-            <a:ext cx="128016" cy="128016"/>
-          </a:xfrm>
-          <a:prstGeom prst="ellipse">
-            <a:avLst/>
-          </a:prstGeom>
-          <a:solidFill>
-            <a:srgbClr val="C4622D"/>
-          </a:solidFill>
-          <a:ln/>
-        </p:spPr>
-      </p:sp>
-      <p:sp>
-        <p:nvSpPr>
-          <p:cNvPr id="6" name="Text 4"/>
-          <p:cNvSpPr/>
-          <p:nvPr/>
-        </p:nvSpPr>
-        <p:spPr>
-          <a:xfrm>
-            <a:off x="914400" y="2084832"/>
-            <a:ext cx="4937760" cy="329184"/>
+          <p:cNvPr id="5" name="Text 3"/>
+          <p:cNvSpPr/>
+          <p:nvPr/>
+        </p:nvSpPr>
+        <p:spPr>
+          <a:xfrm>
+            <a:off x="566928" y="2121408"/>
+            <a:ext cx="5486400" cy="914400"/>
           </a:xfrm>
           <a:prstGeom prst="rect">
             <a:avLst/>
@@ -3533,6 +5254,9 @@
           <a:lstStyle/>
           <a:p>
             <a:pPr indent="0" marL="0">
+              <a:lnSpc>
+                <a:spcPts val="2300"/>
+              </a:lnSpc>
               <a:buNone/>
             </a:pPr>
             <a:r>
@@ -3544,7 +5268,7 @@
                 <a:ea typeface="Calibri" pitchFamily="34" charset="-122"/>
                 <a:cs typeface="Calibri" pitchFamily="34" charset="-120"/>
               </a:rPr>
-              <a:t>Your CRM set up, with every lead in one place</a:t>
+              <a:t>Six stages from new lead to won, fifteen real leads on the board, and dead deals that keep their history.</a:t>
             </a:r>
             <a:endParaRPr lang="en-US" sz="1500" dirty="0"/>
           </a:p>
@@ -3552,34 +5276,36 @@
       </p:sp>
       <p:sp>
         <p:nvSpPr>
-          <p:cNvPr id="7" name="Shape 5"/>
-          <p:cNvSpPr/>
-          <p:nvPr/>
-        </p:nvSpPr>
-        <p:spPr>
-          <a:xfrm>
-            <a:off x="603504" y="2578608"/>
-            <a:ext cx="128016" cy="128016"/>
-          </a:xfrm>
-          <a:prstGeom prst="ellipse">
-            <a:avLst/>
+          <p:cNvPr id="6" name="Shape 4"/>
+          <p:cNvSpPr/>
+          <p:nvPr/>
+        </p:nvSpPr>
+        <p:spPr>
+          <a:xfrm>
+            <a:off x="548640" y="3401568"/>
+            <a:ext cx="5669280" cy="713232"/>
+          </a:xfrm>
+          <a:prstGeom prst="roundRect">
+            <a:avLst>
+              <a:gd name="adj" fmla="val 6410"/>
+            </a:avLst>
           </a:prstGeom>
           <a:solidFill>
-            <a:srgbClr val="C4622D"/>
+            <a:srgbClr val="2C4356"/>
           </a:solidFill>
           <a:ln/>
         </p:spPr>
       </p:sp>
       <p:sp>
         <p:nvSpPr>
-          <p:cNvPr id="8" name="Text 6"/>
-          <p:cNvSpPr/>
-          <p:nvPr/>
-        </p:nvSpPr>
-        <p:spPr>
-          <a:xfrm>
-            <a:off x="914400" y="2487168"/>
-            <a:ext cx="4937760" cy="329184"/>
+          <p:cNvPr id="7" name="Text 5"/>
+          <p:cNvSpPr/>
+          <p:nvPr/>
+        </p:nvSpPr>
+        <p:spPr>
+          <a:xfrm>
+            <a:off x="777240" y="3401568"/>
+            <a:ext cx="5212080" cy="713232"/>
           </a:xfrm>
           <a:prstGeom prst="rect">
             <a:avLst/>
@@ -3595,7 +5321,7 @@
               <a:buNone/>
             </a:pPr>
             <a:r>
-              <a:rPr lang="en-US" sz="1500" dirty="0">
+              <a:rPr lang="en-US" sz="1350" b="1" dirty="0">
                 <a:solidFill>
                   <a:srgbClr val="F6F4EF"/>
                 </a:solidFill>
@@ -3603,42 +5329,76 @@
                 <a:ea typeface="Calibri" pitchFamily="34" charset="-122"/>
                 <a:cs typeface="Calibri" pitchFamily="34" charset="-120"/>
               </a:rPr>
-              <a:t>The funnel and the page that fills it</a:t>
-            </a:r>
-            <a:endParaRPr lang="en-US" sz="1500" dirty="0"/>
-          </a:p>
-        </p:txBody>
-      </p:sp>
-      <p:sp>
-        <p:nvSpPr>
-          <p:cNvPr id="9" name="Shape 7"/>
-          <p:cNvSpPr/>
-          <p:nvPr/>
-        </p:nvSpPr>
-        <p:spPr>
-          <a:xfrm>
-            <a:off x="603504" y="2980944"/>
-            <a:ext cx="128016" cy="128016"/>
+              <a:t>What I can build for you: a pipeline that tells you where money actually stalls.</a:t>
+            </a:r>
+            <a:endParaRPr lang="en-US" sz="1350" dirty="0"/>
+          </a:p>
+        </p:txBody>
+      </p:sp>
+    </p:spTree>
+  </p:cSld>
+  <p:clrMapOvr>
+    <a:masterClrMapping/>
+  </p:clrMapOvr>
+</p:sld>
+</file>
+
+<file path=ppt/slides/slide9.xml><?xml version="1.0" encoding="utf-8"?>
+<p:sld xmlns:a="http://schemas.openxmlformats.org/drawingml/2006/main" xmlns:r="http://schemas.openxmlformats.org/officeDocument/2006/relationships" xmlns:p="http://schemas.openxmlformats.org/presentationml/2006/main">
+  <p:cSld name="Slide 9">
+    <p:bg>
+      <p:bgPr>
+        <a:solidFill>
+          <a:srgbClr val="16232E"/>
+        </a:solidFill>
+      </p:bgPr>
+    </p:bg>
+    <p:spTree>
+      <p:nvGrpSpPr>
+        <p:cNvPr id="1" name=""/>
+        <p:cNvGrpSpPr/>
+        <p:nvPr/>
+      </p:nvGrpSpPr>
+      <p:grpSpPr>
+        <a:xfrm>
+          <a:off x="0" y="0"/>
+          <a:ext cx="0" cy="0"/>
+          <a:chOff x="0" y="0"/>
+          <a:chExt cx="0" cy="0"/>
+        </a:xfrm>
+      </p:grpSpPr>
+      <p:sp>
+        <p:nvSpPr>
+          <p:cNvPr id="2" name="Shape 0"/>
+          <p:cNvSpPr/>
+          <p:nvPr/>
+        </p:nvSpPr>
+        <p:spPr>
+          <a:xfrm>
+            <a:off x="6949440" y="960120"/>
+            <a:ext cx="3108960" cy="3108960"/>
           </a:xfrm>
           <a:prstGeom prst="ellipse">
             <a:avLst/>
           </a:prstGeom>
-          <a:solidFill>
-            <a:srgbClr val="C4622D"/>
-          </a:solidFill>
-          <a:ln/>
-        </p:spPr>
-      </p:sp>
-      <p:sp>
-        <p:nvSpPr>
-          <p:cNvPr id="10" name="Text 8"/>
-          <p:cNvSpPr/>
-          <p:nvPr/>
-        </p:nvSpPr>
-        <p:spPr>
-          <a:xfrm>
-            <a:off x="914400" y="2889504"/>
-            <a:ext cx="4937760" cy="329184"/>
+          <a:ln w="15875">
+            <a:solidFill>
+              <a:srgbClr val="C4622D"/>
+            </a:solidFill>
+            <a:prstDash val="solid"/>
+          </a:ln>
+        </p:spPr>
+      </p:sp>
+      <p:sp>
+        <p:nvSpPr>
+          <p:cNvPr id="3" name="Text 1"/>
+          <p:cNvSpPr/>
+          <p:nvPr/>
+        </p:nvSpPr>
+        <p:spPr>
+          <a:xfrm>
+            <a:off x="566928" y="658368"/>
+            <a:ext cx="1097280" cy="365760"/>
           </a:xfrm>
           <a:prstGeom prst="rect">
             <a:avLst/>
@@ -3654,50 +5414,30 @@
               <a:buNone/>
             </a:pPr>
             <a:r>
-              <a:rPr lang="en-US" sz="1500" dirty="0">
-                <a:solidFill>
-                  <a:srgbClr val="F6F4EF"/>
+              <a:rPr lang="en-US" sz="1200" b="1" spc="240" kern="0" dirty="0">
+                <a:solidFill>
+                  <a:srgbClr val="C4622D"/>
                 </a:solidFill>
                 <a:latin typeface="Calibri" pitchFamily="34" charset="0"/>
                 <a:ea typeface="Calibri" pitchFamily="34" charset="-122"/>
                 <a:cs typeface="Calibri" pitchFamily="34" charset="-120"/>
               </a:rPr>
-              <a:t>The ads that feed the page</a:t>
-            </a:r>
-            <a:endParaRPr lang="en-US" sz="1500" dirty="0"/>
-          </a:p>
-        </p:txBody>
-      </p:sp>
-      <p:sp>
-        <p:nvSpPr>
-          <p:cNvPr id="11" name="Shape 9"/>
-          <p:cNvSpPr/>
-          <p:nvPr/>
-        </p:nvSpPr>
-        <p:spPr>
-          <a:xfrm>
-            <a:off x="603504" y="3383280"/>
-            <a:ext cx="128016" cy="128016"/>
-          </a:xfrm>
-          <a:prstGeom prst="ellipse">
-            <a:avLst/>
-          </a:prstGeom>
-          <a:solidFill>
-            <a:srgbClr val="C4622D"/>
-          </a:solidFill>
-          <a:ln/>
-        </p:spPr>
-      </p:sp>
-      <p:sp>
-        <p:nvSpPr>
-          <p:cNvPr id="12" name="Text 10"/>
-          <p:cNvSpPr/>
-          <p:nvPr/>
-        </p:nvSpPr>
-        <p:spPr>
-          <a:xfrm>
-            <a:off x="914400" y="3291840"/>
-            <a:ext cx="4937760" cy="329184"/>
+              <a:t>04</a:t>
+            </a:r>
+            <a:endParaRPr lang="en-US" sz="1200" dirty="0"/>
+          </a:p>
+        </p:txBody>
+      </p:sp>
+      <p:sp>
+        <p:nvSpPr>
+          <p:cNvPr id="4" name="Text 2"/>
+          <p:cNvSpPr/>
+          <p:nvPr/>
+        </p:nvSpPr>
+        <p:spPr>
+          <a:xfrm>
+            <a:off x="548640" y="1188720"/>
+            <a:ext cx="5852160" cy="731520"/>
           </a:xfrm>
           <a:prstGeom prst="rect">
             <a:avLst/>
@@ -3710,6 +5450,48 @@
           <a:lstStyle/>
           <a:p>
             <a:pPr indent="0" marL="0">
+              <a:buNone/>
+            </a:pPr>
+            <a:r>
+              <a:rPr lang="en-US" sz="4000" b="1" dirty="0">
+                <a:solidFill>
+                  <a:srgbClr val="F6F4EF"/>
+                </a:solidFill>
+                <a:latin typeface="Cambria" pitchFamily="34" charset="0"/>
+                <a:ea typeface="Cambria" pitchFamily="34" charset="-122"/>
+                <a:cs typeface="Cambria" pitchFamily="34" charset="-120"/>
+              </a:rPr>
+              <a:t>The follow-up</a:t>
+            </a:r>
+            <a:endParaRPr lang="en-US" sz="4000" dirty="0"/>
+          </a:p>
+        </p:txBody>
+      </p:sp>
+      <p:sp>
+        <p:nvSpPr>
+          <p:cNvPr id="5" name="Text 3"/>
+          <p:cNvSpPr/>
+          <p:nvPr/>
+        </p:nvSpPr>
+        <p:spPr>
+          <a:xfrm>
+            <a:off x="566928" y="2121408"/>
+            <a:ext cx="5486400" cy="914400"/>
+          </a:xfrm>
+          <a:prstGeom prst="rect">
+            <a:avLst/>
+          </a:prstGeom>
+          <a:noFill/>
+          <a:ln/>
+        </p:spPr>
+        <p:txBody>
+          <a:bodyPr wrap="square" lIns="0" tIns="0" rIns="0" bIns="0" rtlCol="0" anchor="ctr"/>
+          <a:lstStyle/>
+          <a:p>
+            <a:pPr indent="0" marL="0">
+              <a:lnSpc>
+                <a:spcPts val="2300"/>
+              </a:lnSpc>
               <a:buNone/>
             </a:pPr>
             <a:r>
@@ -3721,7 +5503,7 @@
                 <a:ea typeface="Calibri" pitchFamily="34" charset="-122"/>
                 <a:cs typeface="Calibri" pitchFamily="34" charset="-120"/>
               </a:rPr>
-              <a:t>The follow-up that runs on its own</a:t>
+              <a:t>Four workflows. A reply inside sixty seconds, then a sequence that branches on who the lead actually is.</a:t>
             </a:r>
             <a:endParaRPr lang="en-US" sz="1500" dirty="0"/>
           </a:p>
@@ -3729,52 +5511,52 @@
       </p:sp>
       <p:sp>
         <p:nvSpPr>
-          <p:cNvPr id="13" name="Shape 11"/>
-          <p:cNvSpPr/>
-          <p:nvPr/>
-        </p:nvSpPr>
-        <p:spPr>
-          <a:xfrm>
-            <a:off x="5989320" y="2103120"/>
-            <a:ext cx="2606040" cy="841248"/>
+          <p:cNvPr id="6" name="Shape 4"/>
+          <p:cNvSpPr/>
+          <p:nvPr/>
+        </p:nvSpPr>
+        <p:spPr>
+          <a:xfrm>
+            <a:off x="548640" y="3401568"/>
+            <a:ext cx="5669280" cy="713232"/>
           </a:xfrm>
           <a:prstGeom prst="roundRect">
             <a:avLst>
-              <a:gd name="adj" fmla="val 6522"/>
+              <a:gd name="adj" fmla="val 6410"/>
             </a:avLst>
           </a:prstGeom>
           <a:solidFill>
-            <a:srgbClr val="C4622D"/>
+            <a:srgbClr val="2C4356"/>
           </a:solidFill>
           <a:ln/>
         </p:spPr>
       </p:sp>
       <p:sp>
         <p:nvSpPr>
-          <p:cNvPr id="14" name="Text 12"/>
-          <p:cNvSpPr/>
-          <p:nvPr/>
-        </p:nvSpPr>
-        <p:spPr>
-          <a:xfrm>
-            <a:off x="5989320" y="2103120"/>
-            <a:ext cx="2606040" cy="841248"/>
-          </a:xfrm>
-          <a:prstGeom prst="rect">
-            <a:avLst/>
-          </a:prstGeom>
-          <a:noFill/>
-          <a:ln/>
-        </p:spPr>
-        <p:txBody>
-          <a:bodyPr wrap="square" lIns="0" tIns="0" rIns="0" bIns="0" rtlCol="0" anchor="ctr"/>
-          <a:lstStyle/>
-          <a:p>
-            <a:pPr algn="ctr" indent="0" marL="0">
-              <a:buNone/>
-            </a:pPr>
-            <a:r>
-              <a:rPr lang="en-US" sz="1600" b="1" dirty="0">
+          <p:cNvPr id="7" name="Text 5"/>
+          <p:cNvSpPr/>
+          <p:nvPr/>
+        </p:nvSpPr>
+        <p:spPr>
+          <a:xfrm>
+            <a:off x="777240" y="3401568"/>
+            <a:ext cx="5212080" cy="713232"/>
+          </a:xfrm>
+          <a:prstGeom prst="rect">
+            <a:avLst/>
+          </a:prstGeom>
+          <a:noFill/>
+          <a:ln/>
+        </p:spPr>
+        <p:txBody>
+          <a:bodyPr wrap="square" lIns="0" tIns="0" rIns="0" bIns="0" rtlCol="0" anchor="ctr"/>
+          <a:lstStyle/>
+          <a:p>
+            <a:pPr indent="0" marL="0">
+              <a:buNone/>
+            </a:pPr>
+            <a:r>
+              <a:rPr lang="en-US" sz="1350" b="1" dirty="0">
                 <a:solidFill>
                   <a:srgbClr val="F6F4EF"/>
                 </a:solidFill>
@@ -3782,87 +5564,9 @@
                 <a:ea typeface="Calibri" pitchFamily="34" charset="-122"/>
                 <a:cs typeface="Calibri" pitchFamily="34" charset="-120"/>
               </a:rPr>
-              <a:t>Book a call with me</a:t>
-            </a:r>
-            <a:endParaRPr lang="en-US" sz="1600" dirty="0"/>
-          </a:p>
-        </p:txBody>
-      </p:sp>
-      <p:sp>
-        <p:nvSpPr>
-          <p:cNvPr id="15" name="Text 13"/>
-          <p:cNvSpPr/>
-          <p:nvPr/>
-        </p:nvSpPr>
-        <p:spPr>
-          <a:xfrm>
-            <a:off x="5989320" y="3035808"/>
-            <a:ext cx="2606040" cy="274320"/>
-          </a:xfrm>
-          <a:prstGeom prst="rect">
-            <a:avLst/>
-          </a:prstGeom>
-          <a:noFill/>
-          <a:ln/>
-        </p:spPr>
-        <p:txBody>
-          <a:bodyPr wrap="square" lIns="0" tIns="0" rIns="0" bIns="0" rtlCol="0" anchor="ctr"/>
-          <a:lstStyle/>
-          <a:p>
-            <a:pPr algn="ctr" indent="0" marL="0">
-              <a:buNone/>
-            </a:pPr>
-            <a:r>
-              <a:rPr lang="en-US" sz="1050" b="1" spc="60" kern="0" dirty="0">
-                <a:solidFill>
-                  <a:srgbClr val="3E6B57"/>
-                </a:solidFill>
-                <a:latin typeface="Calibri" pitchFamily="34" charset="0"/>
-                <a:ea typeface="Calibri" pitchFamily="34" charset="-122"/>
-                <a:cs typeface="Calibri" pitchFamily="34" charset="-120"/>
-              </a:rPr>
-              <a:t>REPLACE WITH YOUR BOOKING LINK</a:t>
-            </a:r>
-            <a:endParaRPr lang="en-US" sz="1050" dirty="0"/>
-          </a:p>
-        </p:txBody>
-      </p:sp>
-      <p:sp>
-        <p:nvSpPr>
-          <p:cNvPr id="16" name="Text 14"/>
-          <p:cNvSpPr/>
-          <p:nvPr/>
-        </p:nvSpPr>
-        <p:spPr>
-          <a:xfrm>
-            <a:off x="548640" y="4224528"/>
-            <a:ext cx="3657600" cy="292608"/>
-          </a:xfrm>
-          <a:prstGeom prst="rect">
-            <a:avLst/>
-          </a:prstGeom>
-          <a:noFill/>
-          <a:ln/>
-        </p:spPr>
-        <p:txBody>
-          <a:bodyPr wrap="square" lIns="0" tIns="0" rIns="0" bIns="0" rtlCol="0" anchor="ctr"/>
-          <a:lstStyle/>
-          <a:p>
-            <a:pPr indent="0" marL="0">
-              <a:buNone/>
-            </a:pPr>
-            <a:r>
-              <a:rPr lang="en-US" sz="1500" b="1" dirty="0">
-                <a:solidFill>
-                  <a:srgbClr val="F6F4EF"/>
-                </a:solidFill>
-                <a:latin typeface="Cambria" pitchFamily="34" charset="0"/>
-                <a:ea typeface="Cambria" pitchFamily="34" charset="-122"/>
-                <a:cs typeface="Cambria" pitchFamily="34" charset="-120"/>
-              </a:rPr>
-              <a:t>Peter Gutierrez</a:t>
-            </a:r>
-            <a:endParaRPr lang="en-US" sz="1500" dirty="0"/>
+              <a:t>What I can build for you: the part that runs when nobody is at their desk.</a:t>
+            </a:r>
+            <a:endParaRPr lang="en-US" sz="1350" dirty="0"/>
           </a:p>
         </p:txBody>
       </p:sp>

</xml_diff>